<commit_message>
Remove "Slide" text from footer
</commit_message>
<xml_diff>
--- a/working-template.pptx
+++ b/working-template.pptx
@@ -211,7 +211,7 @@
           <a:p>
             <a:fld id="{0F9C1CCF-B725-44A7-AA57-5E433BD85C9F}" type="datetimeFigureOut">
               <a:rPr lang="en-US" smtClean="0"/>
-              <a:t>9/23/26</a:t>
+              <a:t>10/6/26</a:t>
             </a:fld>
             <a:endParaRPr lang="en-US"/>
           </a:p>
@@ -928,10 +928,6 @@
           <a:lstStyle/>
           <a:p>
             <a:pPr algn="ctr"/>
-            <a:r>
-              <a:rPr lang="en-US"/>
-              <a:t>Slide </a:t>
-            </a:r>
             <a:fld id="{C5EF2332-01BF-834F-8236-50238282D533}" type="slidenum">
               <a:rPr lang="en-US" smtClean="0"/>
               <a:pPr algn="ctr"/>
@@ -1141,10 +1137,6 @@
           <a:lstStyle/>
           <a:p>
             <a:pPr algn="ctr"/>
-            <a:r>
-              <a:rPr lang="en-US"/>
-              <a:t>Slide </a:t>
-            </a:r>
             <a:fld id="{C5EF2332-01BF-834F-8236-50238282D533}" type="slidenum">
               <a:rPr lang="en-US" smtClean="0"/>
               <a:pPr algn="ctr"/>
@@ -1398,10 +1390,6 @@
           <a:lstStyle/>
           <a:p>
             <a:pPr algn="ctr"/>
-            <a:r>
-              <a:rPr lang="en-US"/>
-              <a:t>Slide </a:t>
-            </a:r>
             <a:fld id="{C5EF2332-01BF-834F-8236-50238282D533}" type="slidenum">
               <a:rPr lang="en-US" smtClean="0"/>
               <a:pPr algn="ctr"/>
@@ -1645,10 +1633,6 @@
           <a:lstStyle/>
           <a:p>
             <a:pPr algn="ctr"/>
-            <a:r>
-              <a:rPr lang="en-US"/>
-              <a:t>Slide </a:t>
-            </a:r>
             <a:fld id="{C5EF2332-01BF-834F-8236-50238282D533}" type="slidenum">
               <a:rPr lang="en-US" smtClean="0"/>
               <a:pPr algn="ctr"/>
@@ -1969,10 +1953,6 @@
           <a:lstStyle/>
           <a:p>
             <a:pPr algn="ctr"/>
-            <a:r>
-              <a:rPr lang="en-US"/>
-              <a:t>Slide </a:t>
-            </a:r>
             <a:fld id="{C5EF2332-01BF-834F-8236-50238282D533}" type="slidenum">
               <a:rPr lang="en-US" smtClean="0"/>
               <a:pPr algn="ctr"/>
@@ -2333,10 +2313,6 @@
           <a:lstStyle/>
           <a:p>
             <a:pPr algn="ctr"/>
-            <a:r>
-              <a:rPr lang="en-US"/>
-              <a:t>Slide </a:t>
-            </a:r>
             <a:fld id="{C5EF2332-01BF-834F-8236-50238282D533}" type="slidenum">
               <a:rPr lang="en-US" smtClean="0"/>
               <a:pPr algn="ctr"/>
@@ -2831,10 +2807,6 @@
           <a:lstStyle/>
           <a:p>
             <a:pPr algn="ctr"/>
-            <a:r>
-              <a:rPr lang="en-US"/>
-              <a:t>Slide </a:t>
-            </a:r>
             <a:fld id="{C5EF2332-01BF-834F-8236-50238282D533}" type="slidenum">
               <a:rPr lang="en-US" smtClean="0"/>
               <a:pPr algn="ctr"/>
@@ -3027,10 +2999,6 @@
           <a:lstStyle/>
           <a:p>
             <a:pPr algn="ctr"/>
-            <a:r>
-              <a:rPr lang="en-US"/>
-              <a:t>Slide </a:t>
-            </a:r>
             <a:fld id="{C5EF2332-01BF-834F-8236-50238282D533}" type="slidenum">
               <a:rPr lang="en-US" smtClean="0"/>
               <a:pPr algn="ctr"/>
@@ -3201,10 +3169,6 @@
           <a:lstStyle/>
           <a:p>
             <a:pPr algn="ctr"/>
-            <a:r>
-              <a:rPr lang="en-US"/>
-              <a:t>Slide </a:t>
-            </a:r>
             <a:fld id="{C5EF2332-01BF-834F-8236-50238282D533}" type="slidenum">
               <a:rPr lang="en-US" smtClean="0"/>
               <a:pPr algn="ctr"/>
@@ -3555,10 +3519,6 @@
           <a:lstStyle/>
           <a:p>
             <a:pPr algn="ctr"/>
-            <a:r>
-              <a:rPr lang="en-US"/>
-              <a:t>Slide </a:t>
-            </a:r>
             <a:fld id="{C5EF2332-01BF-834F-8236-50238282D533}" type="slidenum">
               <a:rPr lang="en-US" smtClean="0"/>
               <a:pPr algn="ctr"/>
@@ -3886,10 +3846,6 @@
           <a:lstStyle/>
           <a:p>
             <a:pPr algn="ctr"/>
-            <a:r>
-              <a:rPr lang="en-US"/>
-              <a:t>Slide </a:t>
-            </a:r>
             <a:fld id="{C5EF2332-01BF-834F-8236-50238282D533}" type="slidenum">
               <a:rPr lang="en-US" smtClean="0"/>
               <a:pPr algn="ctr"/>
@@ -4193,10 +4149,6 @@
           </a:lstStyle>
           <a:p>
             <a:pPr algn="ctr"/>
-            <a:r>
-              <a:rPr lang="en-US" dirty="0"/>
-              <a:t>Slide </a:t>
-            </a:r>
             <a:fld id="{C5EF2332-01BF-834F-8236-50238282D533}" type="slidenum">
               <a:rPr lang="en-US" smtClean="0"/>
               <a:pPr algn="ctr"/>

</xml_diff>

<commit_message>
Change footer page number location
</commit_message>
<xml_diff>
--- a/working-template.pptx
+++ b/working-template.pptx
@@ -849,10 +849,10 @@
       </p:sp>
       <p:sp>
         <p:nvSpPr>
-          <p:cNvPr id="7" name="Date Placeholder 6">
+          <p:cNvPr id="13" name="Date Placeholder 12">
             <a:extLst>
               <a:ext uri="{FF2B5EF4-FFF2-40B4-BE49-F238E27FC236}">
-                <a16:creationId xmlns:a16="http://schemas.microsoft.com/office/drawing/2014/main" id="{061B09C1-B224-518F-0685-9136C57B0AAB}"/>
+                <a16:creationId xmlns:a16="http://schemas.microsoft.com/office/drawing/2014/main" id="{A98AF039-CAB9-D195-284D-DDC75DFBA39C}"/>
               </a:ext>
             </a:extLst>
           </p:cNvPr>
@@ -879,10 +879,10 @@
       </p:sp>
       <p:sp>
         <p:nvSpPr>
-          <p:cNvPr id="8" name="Footer Placeholder 7">
+          <p:cNvPr id="14" name="Footer Placeholder 13">
             <a:extLst>
               <a:ext uri="{FF2B5EF4-FFF2-40B4-BE49-F238E27FC236}">
-                <a16:creationId xmlns:a16="http://schemas.microsoft.com/office/drawing/2014/main" id="{DF1B80E6-457B-EDED-0211-B71E2739445B}"/>
+                <a16:creationId xmlns:a16="http://schemas.microsoft.com/office/drawing/2014/main" id="{92325642-A61C-3078-0A08-00C186300EA9}"/>
               </a:ext>
             </a:extLst>
           </p:cNvPr>
@@ -908,10 +908,10 @@
       </p:sp>
       <p:sp>
         <p:nvSpPr>
-          <p:cNvPr id="9" name="Slide Number Placeholder 8">
+          <p:cNvPr id="15" name="Slide Number Placeholder 14">
             <a:extLst>
               <a:ext uri="{FF2B5EF4-FFF2-40B4-BE49-F238E27FC236}">
-                <a16:creationId xmlns:a16="http://schemas.microsoft.com/office/drawing/2014/main" id="{9A738F11-4DF9-41BE-57C0-5A8B98080E05}"/>
+                <a16:creationId xmlns:a16="http://schemas.microsoft.com/office/drawing/2014/main" id="{68E9BE78-1F37-C669-71F3-F3AC2F8BB498}"/>
               </a:ext>
             </a:extLst>
           </p:cNvPr>
@@ -927,10 +927,9 @@
           <a:bodyPr/>
           <a:lstStyle/>
           <a:p>
-            <a:pPr algn="ctr"/>
             <a:fld id="{C5EF2332-01BF-834F-8236-50238282D533}" type="slidenum">
               <a:rPr lang="en-US" smtClean="0"/>
-              <a:pPr algn="ctr"/>
+              <a:pPr/>
               <a:t>‹#›</a:t>
             </a:fld>
             <a:endParaRPr lang="en-US" dirty="0"/>
@@ -1058,96 +1057,6 @@
       </p:sp>
       <p:sp>
         <p:nvSpPr>
-          <p:cNvPr id="7" name="Date Placeholder 6">
-            <a:extLst>
-              <a:ext uri="{FF2B5EF4-FFF2-40B4-BE49-F238E27FC236}">
-                <a16:creationId xmlns:a16="http://schemas.microsoft.com/office/drawing/2014/main" id="{1633ABB9-0FD6-00F4-2186-D3425C9073F8}"/>
-              </a:ext>
-            </a:extLst>
-          </p:cNvPr>
-          <p:cNvSpPr>
-            <a:spLocks noGrp="1"/>
-          </p:cNvSpPr>
-          <p:nvPr>
-            <p:ph type="dt" sz="half" idx="10"/>
-          </p:nvPr>
-        </p:nvSpPr>
-        <p:spPr/>
-        <p:txBody>
-          <a:bodyPr/>
-          <a:lstStyle/>
-          <a:p>
-            <a:pPr algn="ctr"/>
-            <a:r>
-              <a:rPr lang="en-US"/>
-              <a:t>DATE</a:t>
-            </a:r>
-            <a:endParaRPr lang="en-US" dirty="0"/>
-          </a:p>
-        </p:txBody>
-      </p:sp>
-      <p:sp>
-        <p:nvSpPr>
-          <p:cNvPr id="8" name="Footer Placeholder 7">
-            <a:extLst>
-              <a:ext uri="{FF2B5EF4-FFF2-40B4-BE49-F238E27FC236}">
-                <a16:creationId xmlns:a16="http://schemas.microsoft.com/office/drawing/2014/main" id="{2CF2A15A-E38D-BBA2-F6E5-F54E8EE4FC5E}"/>
-              </a:ext>
-            </a:extLst>
-          </p:cNvPr>
-          <p:cNvSpPr>
-            <a:spLocks noGrp="1"/>
-          </p:cNvSpPr>
-          <p:nvPr>
-            <p:ph type="ftr" sz="quarter" idx="11"/>
-          </p:nvPr>
-        </p:nvSpPr>
-        <p:spPr/>
-        <p:txBody>
-          <a:bodyPr/>
-          <a:lstStyle/>
-          <a:p>
-            <a:r>
-              <a:rPr lang="en-US"/>
-              <a:t>© LMU Open Science Center</a:t>
-            </a:r>
-            <a:endParaRPr lang="en-US" dirty="0"/>
-          </a:p>
-        </p:txBody>
-      </p:sp>
-      <p:sp>
-        <p:nvSpPr>
-          <p:cNvPr id="9" name="Slide Number Placeholder 8">
-            <a:extLst>
-              <a:ext uri="{FF2B5EF4-FFF2-40B4-BE49-F238E27FC236}">
-                <a16:creationId xmlns:a16="http://schemas.microsoft.com/office/drawing/2014/main" id="{C752F930-079C-2B09-0620-3D5F46770B5E}"/>
-              </a:ext>
-            </a:extLst>
-          </p:cNvPr>
-          <p:cNvSpPr>
-            <a:spLocks noGrp="1"/>
-          </p:cNvSpPr>
-          <p:nvPr>
-            <p:ph type="sldNum" sz="quarter" idx="12"/>
-          </p:nvPr>
-        </p:nvSpPr>
-        <p:spPr/>
-        <p:txBody>
-          <a:bodyPr/>
-          <a:lstStyle/>
-          <a:p>
-            <a:pPr algn="ctr"/>
-            <a:fld id="{C5EF2332-01BF-834F-8236-50238282D533}" type="slidenum">
-              <a:rPr lang="en-US" smtClean="0"/>
-              <a:pPr algn="ctr"/>
-              <a:t>‹#›</a:t>
-            </a:fld>
-            <a:endParaRPr lang="en-US" dirty="0"/>
-          </a:p>
-        </p:txBody>
-      </p:sp>
-      <p:sp>
-        <p:nvSpPr>
           <p:cNvPr id="4" name="Rectangle 3">
             <a:extLst>
               <a:ext uri="{FF2B5EF4-FFF2-40B4-BE49-F238E27FC236}">
@@ -1193,6 +1102,95 @@
           <a:p>
             <a:pPr algn="ctr"/>
             <a:endParaRPr lang="en-US" sz="3200"/>
+          </a:p>
+        </p:txBody>
+      </p:sp>
+      <p:sp>
+        <p:nvSpPr>
+          <p:cNvPr id="5" name="Date Placeholder 4">
+            <a:extLst>
+              <a:ext uri="{FF2B5EF4-FFF2-40B4-BE49-F238E27FC236}">
+                <a16:creationId xmlns:a16="http://schemas.microsoft.com/office/drawing/2014/main" id="{D2DF6E15-AA63-3763-7F86-DACADBA35FC9}"/>
+              </a:ext>
+            </a:extLst>
+          </p:cNvPr>
+          <p:cNvSpPr>
+            <a:spLocks noGrp="1"/>
+          </p:cNvSpPr>
+          <p:nvPr>
+            <p:ph type="dt" sz="half" idx="10"/>
+          </p:nvPr>
+        </p:nvSpPr>
+        <p:spPr/>
+        <p:txBody>
+          <a:bodyPr/>
+          <a:lstStyle/>
+          <a:p>
+            <a:pPr algn="ctr"/>
+            <a:r>
+              <a:rPr lang="en-US"/>
+              <a:t>DATE</a:t>
+            </a:r>
+            <a:endParaRPr lang="en-US" dirty="0"/>
+          </a:p>
+        </p:txBody>
+      </p:sp>
+      <p:sp>
+        <p:nvSpPr>
+          <p:cNvPr id="6" name="Footer Placeholder 5">
+            <a:extLst>
+              <a:ext uri="{FF2B5EF4-FFF2-40B4-BE49-F238E27FC236}">
+                <a16:creationId xmlns:a16="http://schemas.microsoft.com/office/drawing/2014/main" id="{2FD9BD05-D78E-3984-8BF6-5DC5BAB2C98D}"/>
+              </a:ext>
+            </a:extLst>
+          </p:cNvPr>
+          <p:cNvSpPr>
+            <a:spLocks noGrp="1"/>
+          </p:cNvSpPr>
+          <p:nvPr>
+            <p:ph type="ftr" sz="quarter" idx="11"/>
+          </p:nvPr>
+        </p:nvSpPr>
+        <p:spPr/>
+        <p:txBody>
+          <a:bodyPr/>
+          <a:lstStyle/>
+          <a:p>
+            <a:r>
+              <a:rPr lang="en-US"/>
+              <a:t>© LMU Open Science Center</a:t>
+            </a:r>
+            <a:endParaRPr lang="en-US" dirty="0"/>
+          </a:p>
+        </p:txBody>
+      </p:sp>
+      <p:sp>
+        <p:nvSpPr>
+          <p:cNvPr id="10" name="Slide Number Placeholder 9">
+            <a:extLst>
+              <a:ext uri="{FF2B5EF4-FFF2-40B4-BE49-F238E27FC236}">
+                <a16:creationId xmlns:a16="http://schemas.microsoft.com/office/drawing/2014/main" id="{84583088-CCF2-B670-1C52-71D2A0DA5FBC}"/>
+              </a:ext>
+            </a:extLst>
+          </p:cNvPr>
+          <p:cNvSpPr>
+            <a:spLocks noGrp="1"/>
+          </p:cNvSpPr>
+          <p:nvPr>
+            <p:ph type="sldNum" sz="quarter" idx="12"/>
+          </p:nvPr>
+        </p:nvSpPr>
+        <p:spPr/>
+        <p:txBody>
+          <a:bodyPr/>
+          <a:lstStyle/>
+          <a:p>
+            <a:fld id="{C5EF2332-01BF-834F-8236-50238282D533}" type="slidenum">
+              <a:rPr lang="en-US" smtClean="0"/>
+              <a:pPr/>
+              <a:t>‹#›</a:t>
+            </a:fld>
+            <a:endParaRPr lang="en-US" dirty="0"/>
           </a:p>
         </p:txBody>
       </p:sp>
@@ -1311,96 +1309,6 @@
       </p:sp>
       <p:sp>
         <p:nvSpPr>
-          <p:cNvPr id="7" name="Date Placeholder 6">
-            <a:extLst>
-              <a:ext uri="{FF2B5EF4-FFF2-40B4-BE49-F238E27FC236}">
-                <a16:creationId xmlns:a16="http://schemas.microsoft.com/office/drawing/2014/main" id="{DE35559A-56D2-4FD7-4D20-D71F4C8215E0}"/>
-              </a:ext>
-            </a:extLst>
-          </p:cNvPr>
-          <p:cNvSpPr>
-            <a:spLocks noGrp="1"/>
-          </p:cNvSpPr>
-          <p:nvPr>
-            <p:ph type="dt" sz="half" idx="10"/>
-          </p:nvPr>
-        </p:nvSpPr>
-        <p:spPr/>
-        <p:txBody>
-          <a:bodyPr/>
-          <a:lstStyle/>
-          <a:p>
-            <a:pPr algn="ctr"/>
-            <a:r>
-              <a:rPr lang="en-US"/>
-              <a:t>DATE</a:t>
-            </a:r>
-            <a:endParaRPr lang="en-US" dirty="0"/>
-          </a:p>
-        </p:txBody>
-      </p:sp>
-      <p:sp>
-        <p:nvSpPr>
-          <p:cNvPr id="8" name="Footer Placeholder 7">
-            <a:extLst>
-              <a:ext uri="{FF2B5EF4-FFF2-40B4-BE49-F238E27FC236}">
-                <a16:creationId xmlns:a16="http://schemas.microsoft.com/office/drawing/2014/main" id="{4E340C61-838A-D2E9-36F0-C1EB6496D16C}"/>
-              </a:ext>
-            </a:extLst>
-          </p:cNvPr>
-          <p:cNvSpPr>
-            <a:spLocks noGrp="1"/>
-          </p:cNvSpPr>
-          <p:nvPr>
-            <p:ph type="ftr" sz="quarter" idx="11"/>
-          </p:nvPr>
-        </p:nvSpPr>
-        <p:spPr/>
-        <p:txBody>
-          <a:bodyPr/>
-          <a:lstStyle/>
-          <a:p>
-            <a:r>
-              <a:rPr lang="en-US"/>
-              <a:t>© LMU Open Science Center</a:t>
-            </a:r>
-            <a:endParaRPr lang="en-US" dirty="0"/>
-          </a:p>
-        </p:txBody>
-      </p:sp>
-      <p:sp>
-        <p:nvSpPr>
-          <p:cNvPr id="9" name="Slide Number Placeholder 8">
-            <a:extLst>
-              <a:ext uri="{FF2B5EF4-FFF2-40B4-BE49-F238E27FC236}">
-                <a16:creationId xmlns:a16="http://schemas.microsoft.com/office/drawing/2014/main" id="{C0F46CA0-DC5C-0E94-9C04-A3785DB5CE53}"/>
-              </a:ext>
-            </a:extLst>
-          </p:cNvPr>
-          <p:cNvSpPr>
-            <a:spLocks noGrp="1"/>
-          </p:cNvSpPr>
-          <p:nvPr>
-            <p:ph type="sldNum" sz="quarter" idx="12"/>
-          </p:nvPr>
-        </p:nvSpPr>
-        <p:spPr/>
-        <p:txBody>
-          <a:bodyPr/>
-          <a:lstStyle/>
-          <a:p>
-            <a:pPr algn="ctr"/>
-            <a:fld id="{C5EF2332-01BF-834F-8236-50238282D533}" type="slidenum">
-              <a:rPr lang="en-US" smtClean="0"/>
-              <a:pPr algn="ctr"/>
-              <a:t>‹#›</a:t>
-            </a:fld>
-            <a:endParaRPr lang="en-US" dirty="0"/>
-          </a:p>
-        </p:txBody>
-      </p:sp>
-      <p:sp>
-        <p:nvSpPr>
           <p:cNvPr id="4" name="Rectangle 3">
             <a:extLst>
               <a:ext uri="{FF2B5EF4-FFF2-40B4-BE49-F238E27FC236}">
@@ -1446,6 +1354,95 @@
           <a:p>
             <a:pPr algn="ctr"/>
             <a:endParaRPr lang="en-US" sz="3200"/>
+          </a:p>
+        </p:txBody>
+      </p:sp>
+      <p:sp>
+        <p:nvSpPr>
+          <p:cNvPr id="5" name="Date Placeholder 4">
+            <a:extLst>
+              <a:ext uri="{FF2B5EF4-FFF2-40B4-BE49-F238E27FC236}">
+                <a16:creationId xmlns:a16="http://schemas.microsoft.com/office/drawing/2014/main" id="{5BF45B85-27C4-5A2F-EC81-52FBC9699338}"/>
+              </a:ext>
+            </a:extLst>
+          </p:cNvPr>
+          <p:cNvSpPr>
+            <a:spLocks noGrp="1"/>
+          </p:cNvSpPr>
+          <p:nvPr>
+            <p:ph type="dt" sz="half" idx="10"/>
+          </p:nvPr>
+        </p:nvSpPr>
+        <p:spPr/>
+        <p:txBody>
+          <a:bodyPr/>
+          <a:lstStyle/>
+          <a:p>
+            <a:pPr algn="ctr"/>
+            <a:r>
+              <a:rPr lang="en-US"/>
+              <a:t>DATE</a:t>
+            </a:r>
+            <a:endParaRPr lang="en-US" dirty="0"/>
+          </a:p>
+        </p:txBody>
+      </p:sp>
+      <p:sp>
+        <p:nvSpPr>
+          <p:cNvPr id="6" name="Footer Placeholder 5">
+            <a:extLst>
+              <a:ext uri="{FF2B5EF4-FFF2-40B4-BE49-F238E27FC236}">
+                <a16:creationId xmlns:a16="http://schemas.microsoft.com/office/drawing/2014/main" id="{8F83EC60-CE7B-06F0-476B-80CB9CE1F2F7}"/>
+              </a:ext>
+            </a:extLst>
+          </p:cNvPr>
+          <p:cNvSpPr>
+            <a:spLocks noGrp="1"/>
+          </p:cNvSpPr>
+          <p:nvPr>
+            <p:ph type="ftr" sz="quarter" idx="11"/>
+          </p:nvPr>
+        </p:nvSpPr>
+        <p:spPr/>
+        <p:txBody>
+          <a:bodyPr/>
+          <a:lstStyle/>
+          <a:p>
+            <a:r>
+              <a:rPr lang="en-US"/>
+              <a:t>© LMU Open Science Center</a:t>
+            </a:r>
+            <a:endParaRPr lang="en-US" dirty="0"/>
+          </a:p>
+        </p:txBody>
+      </p:sp>
+      <p:sp>
+        <p:nvSpPr>
+          <p:cNvPr id="10" name="Slide Number Placeholder 9">
+            <a:extLst>
+              <a:ext uri="{FF2B5EF4-FFF2-40B4-BE49-F238E27FC236}">
+                <a16:creationId xmlns:a16="http://schemas.microsoft.com/office/drawing/2014/main" id="{8A9AB982-9F02-36B3-80ED-6CFB05C75363}"/>
+              </a:ext>
+            </a:extLst>
+          </p:cNvPr>
+          <p:cNvSpPr>
+            <a:spLocks noGrp="1"/>
+          </p:cNvSpPr>
+          <p:nvPr>
+            <p:ph type="sldNum" sz="quarter" idx="12"/>
+          </p:nvPr>
+        </p:nvSpPr>
+        <p:spPr/>
+        <p:txBody>
+          <a:bodyPr/>
+          <a:lstStyle/>
+          <a:p>
+            <a:fld id="{C5EF2332-01BF-834F-8236-50238282D533}" type="slidenum">
+              <a:rPr lang="en-US" smtClean="0"/>
+              <a:pPr/>
+              <a:t>‹#›</a:t>
+            </a:fld>
+            <a:endParaRPr lang="en-US" dirty="0"/>
           </a:p>
         </p:txBody>
       </p:sp>
@@ -1554,96 +1551,6 @@
       </p:sp>
       <p:sp>
         <p:nvSpPr>
-          <p:cNvPr id="7" name="Date Placeholder 6">
-            <a:extLst>
-              <a:ext uri="{FF2B5EF4-FFF2-40B4-BE49-F238E27FC236}">
-                <a16:creationId xmlns:a16="http://schemas.microsoft.com/office/drawing/2014/main" id="{E2ED1F55-3CE9-F618-3510-EE96FDC54304}"/>
-              </a:ext>
-            </a:extLst>
-          </p:cNvPr>
-          <p:cNvSpPr>
-            <a:spLocks noGrp="1"/>
-          </p:cNvSpPr>
-          <p:nvPr>
-            <p:ph type="dt" sz="half" idx="10"/>
-          </p:nvPr>
-        </p:nvSpPr>
-        <p:spPr/>
-        <p:txBody>
-          <a:bodyPr/>
-          <a:lstStyle/>
-          <a:p>
-            <a:pPr algn="ctr"/>
-            <a:r>
-              <a:rPr lang="en-US"/>
-              <a:t>DATE</a:t>
-            </a:r>
-            <a:endParaRPr lang="en-US" dirty="0"/>
-          </a:p>
-        </p:txBody>
-      </p:sp>
-      <p:sp>
-        <p:nvSpPr>
-          <p:cNvPr id="8" name="Footer Placeholder 7">
-            <a:extLst>
-              <a:ext uri="{FF2B5EF4-FFF2-40B4-BE49-F238E27FC236}">
-                <a16:creationId xmlns:a16="http://schemas.microsoft.com/office/drawing/2014/main" id="{0616AEA6-DD6E-40D4-2DDA-E355C068ABA2}"/>
-              </a:ext>
-            </a:extLst>
-          </p:cNvPr>
-          <p:cNvSpPr>
-            <a:spLocks noGrp="1"/>
-          </p:cNvSpPr>
-          <p:nvPr>
-            <p:ph type="ftr" sz="quarter" idx="11"/>
-          </p:nvPr>
-        </p:nvSpPr>
-        <p:spPr/>
-        <p:txBody>
-          <a:bodyPr/>
-          <a:lstStyle/>
-          <a:p>
-            <a:r>
-              <a:rPr lang="en-US"/>
-              <a:t>© LMU Open Science Center</a:t>
-            </a:r>
-            <a:endParaRPr lang="en-US" dirty="0"/>
-          </a:p>
-        </p:txBody>
-      </p:sp>
-      <p:sp>
-        <p:nvSpPr>
-          <p:cNvPr id="9" name="Slide Number Placeholder 8">
-            <a:extLst>
-              <a:ext uri="{FF2B5EF4-FFF2-40B4-BE49-F238E27FC236}">
-                <a16:creationId xmlns:a16="http://schemas.microsoft.com/office/drawing/2014/main" id="{BD632E70-5D06-CAE0-ED30-149A6C1E3F1E}"/>
-              </a:ext>
-            </a:extLst>
-          </p:cNvPr>
-          <p:cNvSpPr>
-            <a:spLocks noGrp="1"/>
-          </p:cNvSpPr>
-          <p:nvPr>
-            <p:ph type="sldNum" sz="quarter" idx="12"/>
-          </p:nvPr>
-        </p:nvSpPr>
-        <p:spPr/>
-        <p:txBody>
-          <a:bodyPr/>
-          <a:lstStyle/>
-          <a:p>
-            <a:pPr algn="ctr"/>
-            <a:fld id="{C5EF2332-01BF-834F-8236-50238282D533}" type="slidenum">
-              <a:rPr lang="en-US" smtClean="0"/>
-              <a:pPr algn="ctr"/>
-              <a:t>‹#›</a:t>
-            </a:fld>
-            <a:endParaRPr lang="en-US" dirty="0"/>
-          </a:p>
-        </p:txBody>
-      </p:sp>
-      <p:sp>
-        <p:nvSpPr>
           <p:cNvPr id="4" name="Rectangle 3">
             <a:extLst>
               <a:ext uri="{FF2B5EF4-FFF2-40B4-BE49-F238E27FC236}">
@@ -1689,6 +1596,95 @@
           <a:p>
             <a:pPr algn="ctr"/>
             <a:endParaRPr lang="en-US" sz="3200"/>
+          </a:p>
+        </p:txBody>
+      </p:sp>
+      <p:sp>
+        <p:nvSpPr>
+          <p:cNvPr id="11" name="Date Placeholder 10">
+            <a:extLst>
+              <a:ext uri="{FF2B5EF4-FFF2-40B4-BE49-F238E27FC236}">
+                <a16:creationId xmlns:a16="http://schemas.microsoft.com/office/drawing/2014/main" id="{CE3B72D0-0A08-8401-1102-DC8B6D528889}"/>
+              </a:ext>
+            </a:extLst>
+          </p:cNvPr>
+          <p:cNvSpPr>
+            <a:spLocks noGrp="1"/>
+          </p:cNvSpPr>
+          <p:nvPr>
+            <p:ph type="dt" sz="half" idx="10"/>
+          </p:nvPr>
+        </p:nvSpPr>
+        <p:spPr/>
+        <p:txBody>
+          <a:bodyPr/>
+          <a:lstStyle/>
+          <a:p>
+            <a:pPr algn="ctr"/>
+            <a:r>
+              <a:rPr lang="en-US"/>
+              <a:t>DATE</a:t>
+            </a:r>
+            <a:endParaRPr lang="en-US" dirty="0"/>
+          </a:p>
+        </p:txBody>
+      </p:sp>
+      <p:sp>
+        <p:nvSpPr>
+          <p:cNvPr id="12" name="Footer Placeholder 11">
+            <a:extLst>
+              <a:ext uri="{FF2B5EF4-FFF2-40B4-BE49-F238E27FC236}">
+                <a16:creationId xmlns:a16="http://schemas.microsoft.com/office/drawing/2014/main" id="{06FDA1F9-F2A3-54A6-D8DB-F94C2CD5C623}"/>
+              </a:ext>
+            </a:extLst>
+          </p:cNvPr>
+          <p:cNvSpPr>
+            <a:spLocks noGrp="1"/>
+          </p:cNvSpPr>
+          <p:nvPr>
+            <p:ph type="ftr" sz="quarter" idx="11"/>
+          </p:nvPr>
+        </p:nvSpPr>
+        <p:spPr/>
+        <p:txBody>
+          <a:bodyPr/>
+          <a:lstStyle/>
+          <a:p>
+            <a:r>
+              <a:rPr lang="en-US"/>
+              <a:t>© LMU Open Science Center</a:t>
+            </a:r>
+            <a:endParaRPr lang="en-US" dirty="0"/>
+          </a:p>
+        </p:txBody>
+      </p:sp>
+      <p:sp>
+        <p:nvSpPr>
+          <p:cNvPr id="13" name="Slide Number Placeholder 12">
+            <a:extLst>
+              <a:ext uri="{FF2B5EF4-FFF2-40B4-BE49-F238E27FC236}">
+                <a16:creationId xmlns:a16="http://schemas.microsoft.com/office/drawing/2014/main" id="{7FE0A592-9ACE-2460-AAA6-BCEAFC660CD2}"/>
+              </a:ext>
+            </a:extLst>
+          </p:cNvPr>
+          <p:cNvSpPr>
+            <a:spLocks noGrp="1"/>
+          </p:cNvSpPr>
+          <p:nvPr>
+            <p:ph type="sldNum" sz="quarter" idx="12"/>
+          </p:nvPr>
+        </p:nvSpPr>
+        <p:spPr/>
+        <p:txBody>
+          <a:bodyPr/>
+          <a:lstStyle/>
+          <a:p>
+            <a:fld id="{C5EF2332-01BF-834F-8236-50238282D533}" type="slidenum">
+              <a:rPr lang="en-US" smtClean="0"/>
+              <a:pPr/>
+              <a:t>‹#›</a:t>
+            </a:fld>
+            <a:endParaRPr lang="en-US" dirty="0"/>
           </a:p>
         </p:txBody>
       </p:sp>
@@ -1874,96 +1870,6 @@
       </p:sp>
       <p:sp>
         <p:nvSpPr>
-          <p:cNvPr id="7" name="Date Placeholder 6">
-            <a:extLst>
-              <a:ext uri="{FF2B5EF4-FFF2-40B4-BE49-F238E27FC236}">
-                <a16:creationId xmlns:a16="http://schemas.microsoft.com/office/drawing/2014/main" id="{7A3D4B62-A9D4-A224-853C-F47B5EEC33A2}"/>
-              </a:ext>
-            </a:extLst>
-          </p:cNvPr>
-          <p:cNvSpPr>
-            <a:spLocks noGrp="1"/>
-          </p:cNvSpPr>
-          <p:nvPr>
-            <p:ph type="dt" sz="half" idx="10"/>
-          </p:nvPr>
-        </p:nvSpPr>
-        <p:spPr/>
-        <p:txBody>
-          <a:bodyPr/>
-          <a:lstStyle/>
-          <a:p>
-            <a:pPr algn="ctr"/>
-            <a:r>
-              <a:rPr lang="en-US"/>
-              <a:t>DATE</a:t>
-            </a:r>
-            <a:endParaRPr lang="en-US" dirty="0"/>
-          </a:p>
-        </p:txBody>
-      </p:sp>
-      <p:sp>
-        <p:nvSpPr>
-          <p:cNvPr id="8" name="Footer Placeholder 7">
-            <a:extLst>
-              <a:ext uri="{FF2B5EF4-FFF2-40B4-BE49-F238E27FC236}">
-                <a16:creationId xmlns:a16="http://schemas.microsoft.com/office/drawing/2014/main" id="{FC227C7C-21CB-0721-ADC3-A51EEAD51D56}"/>
-              </a:ext>
-            </a:extLst>
-          </p:cNvPr>
-          <p:cNvSpPr>
-            <a:spLocks noGrp="1"/>
-          </p:cNvSpPr>
-          <p:nvPr>
-            <p:ph type="ftr" sz="quarter" idx="11"/>
-          </p:nvPr>
-        </p:nvSpPr>
-        <p:spPr/>
-        <p:txBody>
-          <a:bodyPr/>
-          <a:lstStyle/>
-          <a:p>
-            <a:r>
-              <a:rPr lang="en-US"/>
-              <a:t>© LMU Open Science Center</a:t>
-            </a:r>
-            <a:endParaRPr lang="en-US" dirty="0"/>
-          </a:p>
-        </p:txBody>
-      </p:sp>
-      <p:sp>
-        <p:nvSpPr>
-          <p:cNvPr id="9" name="Slide Number Placeholder 8">
-            <a:extLst>
-              <a:ext uri="{FF2B5EF4-FFF2-40B4-BE49-F238E27FC236}">
-                <a16:creationId xmlns:a16="http://schemas.microsoft.com/office/drawing/2014/main" id="{E630E53C-392D-BD97-174E-961B24066A76}"/>
-              </a:ext>
-            </a:extLst>
-          </p:cNvPr>
-          <p:cNvSpPr>
-            <a:spLocks noGrp="1"/>
-          </p:cNvSpPr>
-          <p:nvPr>
-            <p:ph type="sldNum" sz="quarter" idx="12"/>
-          </p:nvPr>
-        </p:nvSpPr>
-        <p:spPr/>
-        <p:txBody>
-          <a:bodyPr/>
-          <a:lstStyle/>
-          <a:p>
-            <a:pPr algn="ctr"/>
-            <a:fld id="{C5EF2332-01BF-834F-8236-50238282D533}" type="slidenum">
-              <a:rPr lang="en-US" smtClean="0"/>
-              <a:pPr algn="ctr"/>
-              <a:t>‹#›</a:t>
-            </a:fld>
-            <a:endParaRPr lang="en-US" dirty="0"/>
-          </a:p>
-        </p:txBody>
-      </p:sp>
-      <p:sp>
-        <p:nvSpPr>
           <p:cNvPr id="4" name="Rectangle 3">
             <a:extLst>
               <a:ext uri="{FF2B5EF4-FFF2-40B4-BE49-F238E27FC236}">
@@ -2009,6 +1915,95 @@
           <a:p>
             <a:pPr algn="ctr"/>
             <a:endParaRPr lang="en-US" sz="3200"/>
+          </a:p>
+        </p:txBody>
+      </p:sp>
+      <p:sp>
+        <p:nvSpPr>
+          <p:cNvPr id="5" name="Date Placeholder 4">
+            <a:extLst>
+              <a:ext uri="{FF2B5EF4-FFF2-40B4-BE49-F238E27FC236}">
+                <a16:creationId xmlns:a16="http://schemas.microsoft.com/office/drawing/2014/main" id="{CA956807-87AD-1B61-6635-A4BD697312DD}"/>
+              </a:ext>
+            </a:extLst>
+          </p:cNvPr>
+          <p:cNvSpPr>
+            <a:spLocks noGrp="1"/>
+          </p:cNvSpPr>
+          <p:nvPr>
+            <p:ph type="dt" sz="half" idx="10"/>
+          </p:nvPr>
+        </p:nvSpPr>
+        <p:spPr/>
+        <p:txBody>
+          <a:bodyPr/>
+          <a:lstStyle/>
+          <a:p>
+            <a:pPr algn="ctr"/>
+            <a:r>
+              <a:rPr lang="en-US"/>
+              <a:t>DATE</a:t>
+            </a:r>
+            <a:endParaRPr lang="en-US" dirty="0"/>
+          </a:p>
+        </p:txBody>
+      </p:sp>
+      <p:sp>
+        <p:nvSpPr>
+          <p:cNvPr id="6" name="Footer Placeholder 5">
+            <a:extLst>
+              <a:ext uri="{FF2B5EF4-FFF2-40B4-BE49-F238E27FC236}">
+                <a16:creationId xmlns:a16="http://schemas.microsoft.com/office/drawing/2014/main" id="{A848E190-73C6-8A24-D8B9-FC7B080DD00D}"/>
+              </a:ext>
+            </a:extLst>
+          </p:cNvPr>
+          <p:cNvSpPr>
+            <a:spLocks noGrp="1"/>
+          </p:cNvSpPr>
+          <p:nvPr>
+            <p:ph type="ftr" sz="quarter" idx="11"/>
+          </p:nvPr>
+        </p:nvSpPr>
+        <p:spPr/>
+        <p:txBody>
+          <a:bodyPr/>
+          <a:lstStyle/>
+          <a:p>
+            <a:r>
+              <a:rPr lang="en-US"/>
+              <a:t>© LMU Open Science Center</a:t>
+            </a:r>
+            <a:endParaRPr lang="en-US" dirty="0"/>
+          </a:p>
+        </p:txBody>
+      </p:sp>
+      <p:sp>
+        <p:nvSpPr>
+          <p:cNvPr id="10" name="Slide Number Placeholder 9">
+            <a:extLst>
+              <a:ext uri="{FF2B5EF4-FFF2-40B4-BE49-F238E27FC236}">
+                <a16:creationId xmlns:a16="http://schemas.microsoft.com/office/drawing/2014/main" id="{A4B39B83-B2B9-A607-75FD-CC4196FDAB48}"/>
+              </a:ext>
+            </a:extLst>
+          </p:cNvPr>
+          <p:cNvSpPr>
+            <a:spLocks noGrp="1"/>
+          </p:cNvSpPr>
+          <p:nvPr>
+            <p:ph type="sldNum" sz="quarter" idx="12"/>
+          </p:nvPr>
+        </p:nvSpPr>
+        <p:spPr/>
+        <p:txBody>
+          <a:bodyPr/>
+          <a:lstStyle/>
+          <a:p>
+            <a:fld id="{C5EF2332-01BF-834F-8236-50238282D533}" type="slidenum">
+              <a:rPr lang="en-US" smtClean="0"/>
+              <a:pPr/>
+              <a:t>‹#›</a:t>
+            </a:fld>
+            <a:endParaRPr lang="en-US" dirty="0"/>
           </a:p>
         </p:txBody>
       </p:sp>
@@ -2234,96 +2229,6 @@
       </p:sp>
       <p:sp>
         <p:nvSpPr>
-          <p:cNvPr id="8" name="Date Placeholder 7">
-            <a:extLst>
-              <a:ext uri="{FF2B5EF4-FFF2-40B4-BE49-F238E27FC236}">
-                <a16:creationId xmlns:a16="http://schemas.microsoft.com/office/drawing/2014/main" id="{53BFD42A-B99F-B332-F96E-677E56BC9A77}"/>
-              </a:ext>
-            </a:extLst>
-          </p:cNvPr>
-          <p:cNvSpPr>
-            <a:spLocks noGrp="1"/>
-          </p:cNvSpPr>
-          <p:nvPr>
-            <p:ph type="dt" sz="half" idx="10"/>
-          </p:nvPr>
-        </p:nvSpPr>
-        <p:spPr/>
-        <p:txBody>
-          <a:bodyPr/>
-          <a:lstStyle/>
-          <a:p>
-            <a:pPr algn="ctr"/>
-            <a:r>
-              <a:rPr lang="en-US"/>
-              <a:t>DATE</a:t>
-            </a:r>
-            <a:endParaRPr lang="en-US" dirty="0"/>
-          </a:p>
-        </p:txBody>
-      </p:sp>
-      <p:sp>
-        <p:nvSpPr>
-          <p:cNvPr id="9" name="Footer Placeholder 8">
-            <a:extLst>
-              <a:ext uri="{FF2B5EF4-FFF2-40B4-BE49-F238E27FC236}">
-                <a16:creationId xmlns:a16="http://schemas.microsoft.com/office/drawing/2014/main" id="{E7917CDB-D8CE-FB9A-9950-24117F9B85CA}"/>
-              </a:ext>
-            </a:extLst>
-          </p:cNvPr>
-          <p:cNvSpPr>
-            <a:spLocks noGrp="1"/>
-          </p:cNvSpPr>
-          <p:nvPr>
-            <p:ph type="ftr" sz="quarter" idx="11"/>
-          </p:nvPr>
-        </p:nvSpPr>
-        <p:spPr/>
-        <p:txBody>
-          <a:bodyPr/>
-          <a:lstStyle/>
-          <a:p>
-            <a:r>
-              <a:rPr lang="en-US"/>
-              <a:t>© LMU Open Science Center</a:t>
-            </a:r>
-            <a:endParaRPr lang="en-US" dirty="0"/>
-          </a:p>
-        </p:txBody>
-      </p:sp>
-      <p:sp>
-        <p:nvSpPr>
-          <p:cNvPr id="10" name="Slide Number Placeholder 9">
-            <a:extLst>
-              <a:ext uri="{FF2B5EF4-FFF2-40B4-BE49-F238E27FC236}">
-                <a16:creationId xmlns:a16="http://schemas.microsoft.com/office/drawing/2014/main" id="{761EF569-90C9-0E39-2DB2-EBF7BACC7581}"/>
-              </a:ext>
-            </a:extLst>
-          </p:cNvPr>
-          <p:cNvSpPr>
-            <a:spLocks noGrp="1"/>
-          </p:cNvSpPr>
-          <p:nvPr>
-            <p:ph type="sldNum" sz="quarter" idx="12"/>
-          </p:nvPr>
-        </p:nvSpPr>
-        <p:spPr/>
-        <p:txBody>
-          <a:bodyPr/>
-          <a:lstStyle/>
-          <a:p>
-            <a:pPr algn="ctr"/>
-            <a:fld id="{C5EF2332-01BF-834F-8236-50238282D533}" type="slidenum">
-              <a:rPr lang="en-US" smtClean="0"/>
-              <a:pPr algn="ctr"/>
-              <a:t>‹#›</a:t>
-            </a:fld>
-            <a:endParaRPr lang="en-US" dirty="0"/>
-          </a:p>
-        </p:txBody>
-      </p:sp>
-      <p:sp>
-        <p:nvSpPr>
           <p:cNvPr id="5" name="Rectangle 4">
             <a:extLst>
               <a:ext uri="{FF2B5EF4-FFF2-40B4-BE49-F238E27FC236}">
@@ -2369,6 +2274,95 @@
           <a:p>
             <a:pPr algn="ctr"/>
             <a:endParaRPr lang="en-US" sz="3200"/>
+          </a:p>
+        </p:txBody>
+      </p:sp>
+      <p:sp>
+        <p:nvSpPr>
+          <p:cNvPr id="6" name="Date Placeholder 5">
+            <a:extLst>
+              <a:ext uri="{FF2B5EF4-FFF2-40B4-BE49-F238E27FC236}">
+                <a16:creationId xmlns:a16="http://schemas.microsoft.com/office/drawing/2014/main" id="{DB9C105D-2DC4-B9F4-C1FE-2CAFAE38DB01}"/>
+              </a:ext>
+            </a:extLst>
+          </p:cNvPr>
+          <p:cNvSpPr>
+            <a:spLocks noGrp="1"/>
+          </p:cNvSpPr>
+          <p:nvPr>
+            <p:ph type="dt" sz="half" idx="10"/>
+          </p:nvPr>
+        </p:nvSpPr>
+        <p:spPr/>
+        <p:txBody>
+          <a:bodyPr/>
+          <a:lstStyle/>
+          <a:p>
+            <a:pPr algn="ctr"/>
+            <a:r>
+              <a:rPr lang="en-US"/>
+              <a:t>DATE</a:t>
+            </a:r>
+            <a:endParaRPr lang="en-US" dirty="0"/>
+          </a:p>
+        </p:txBody>
+      </p:sp>
+      <p:sp>
+        <p:nvSpPr>
+          <p:cNvPr id="7" name="Footer Placeholder 6">
+            <a:extLst>
+              <a:ext uri="{FF2B5EF4-FFF2-40B4-BE49-F238E27FC236}">
+                <a16:creationId xmlns:a16="http://schemas.microsoft.com/office/drawing/2014/main" id="{B6159A58-99BB-FD20-30B4-B65A749EE7DB}"/>
+              </a:ext>
+            </a:extLst>
+          </p:cNvPr>
+          <p:cNvSpPr>
+            <a:spLocks noGrp="1"/>
+          </p:cNvSpPr>
+          <p:nvPr>
+            <p:ph type="ftr" sz="quarter" idx="11"/>
+          </p:nvPr>
+        </p:nvSpPr>
+        <p:spPr/>
+        <p:txBody>
+          <a:bodyPr/>
+          <a:lstStyle/>
+          <a:p>
+            <a:r>
+              <a:rPr lang="en-US"/>
+              <a:t>© LMU Open Science Center</a:t>
+            </a:r>
+            <a:endParaRPr lang="en-US" dirty="0"/>
+          </a:p>
+        </p:txBody>
+      </p:sp>
+      <p:sp>
+        <p:nvSpPr>
+          <p:cNvPr id="11" name="Slide Number Placeholder 10">
+            <a:extLst>
+              <a:ext uri="{FF2B5EF4-FFF2-40B4-BE49-F238E27FC236}">
+                <a16:creationId xmlns:a16="http://schemas.microsoft.com/office/drawing/2014/main" id="{91EB764C-C70A-BBB6-D634-50E6464DB304}"/>
+              </a:ext>
+            </a:extLst>
+          </p:cNvPr>
+          <p:cNvSpPr>
+            <a:spLocks noGrp="1"/>
+          </p:cNvSpPr>
+          <p:nvPr>
+            <p:ph type="sldNum" sz="quarter" idx="12"/>
+          </p:nvPr>
+        </p:nvSpPr>
+        <p:spPr/>
+        <p:txBody>
+          <a:bodyPr/>
+          <a:lstStyle/>
+          <a:p>
+            <a:fld id="{C5EF2332-01BF-834F-8236-50238282D533}" type="slidenum">
+              <a:rPr lang="en-US" smtClean="0"/>
+              <a:pPr/>
+              <a:t>‹#›</a:t>
+            </a:fld>
+            <a:endParaRPr lang="en-US" dirty="0"/>
           </a:p>
         </p:txBody>
       </p:sp>
@@ -2728,96 +2722,6 @@
       </p:sp>
       <p:sp>
         <p:nvSpPr>
-          <p:cNvPr id="10" name="Date Placeholder 9">
-            <a:extLst>
-              <a:ext uri="{FF2B5EF4-FFF2-40B4-BE49-F238E27FC236}">
-                <a16:creationId xmlns:a16="http://schemas.microsoft.com/office/drawing/2014/main" id="{C6779744-BA8A-1AED-290E-865E62914D1E}"/>
-              </a:ext>
-            </a:extLst>
-          </p:cNvPr>
-          <p:cNvSpPr>
-            <a:spLocks noGrp="1"/>
-          </p:cNvSpPr>
-          <p:nvPr>
-            <p:ph type="dt" sz="half" idx="10"/>
-          </p:nvPr>
-        </p:nvSpPr>
-        <p:spPr/>
-        <p:txBody>
-          <a:bodyPr/>
-          <a:lstStyle/>
-          <a:p>
-            <a:pPr algn="ctr"/>
-            <a:r>
-              <a:rPr lang="en-US"/>
-              <a:t>DATE</a:t>
-            </a:r>
-            <a:endParaRPr lang="en-US" dirty="0"/>
-          </a:p>
-        </p:txBody>
-      </p:sp>
-      <p:sp>
-        <p:nvSpPr>
-          <p:cNvPr id="11" name="Footer Placeholder 10">
-            <a:extLst>
-              <a:ext uri="{FF2B5EF4-FFF2-40B4-BE49-F238E27FC236}">
-                <a16:creationId xmlns:a16="http://schemas.microsoft.com/office/drawing/2014/main" id="{1848E229-50B2-977A-CF44-3D42D1183372}"/>
-              </a:ext>
-            </a:extLst>
-          </p:cNvPr>
-          <p:cNvSpPr>
-            <a:spLocks noGrp="1"/>
-          </p:cNvSpPr>
-          <p:nvPr>
-            <p:ph type="ftr" sz="quarter" idx="11"/>
-          </p:nvPr>
-        </p:nvSpPr>
-        <p:spPr/>
-        <p:txBody>
-          <a:bodyPr/>
-          <a:lstStyle/>
-          <a:p>
-            <a:r>
-              <a:rPr lang="en-US"/>
-              <a:t>© LMU Open Science Center</a:t>
-            </a:r>
-            <a:endParaRPr lang="en-US" dirty="0"/>
-          </a:p>
-        </p:txBody>
-      </p:sp>
-      <p:sp>
-        <p:nvSpPr>
-          <p:cNvPr id="12" name="Slide Number Placeholder 11">
-            <a:extLst>
-              <a:ext uri="{FF2B5EF4-FFF2-40B4-BE49-F238E27FC236}">
-                <a16:creationId xmlns:a16="http://schemas.microsoft.com/office/drawing/2014/main" id="{20842B77-B6EE-65F3-DC92-E2534256F029}"/>
-              </a:ext>
-            </a:extLst>
-          </p:cNvPr>
-          <p:cNvSpPr>
-            <a:spLocks noGrp="1"/>
-          </p:cNvSpPr>
-          <p:nvPr>
-            <p:ph type="sldNum" sz="quarter" idx="12"/>
-          </p:nvPr>
-        </p:nvSpPr>
-        <p:spPr/>
-        <p:txBody>
-          <a:bodyPr/>
-          <a:lstStyle/>
-          <a:p>
-            <a:pPr algn="ctr"/>
-            <a:fld id="{C5EF2332-01BF-834F-8236-50238282D533}" type="slidenum">
-              <a:rPr lang="en-US" smtClean="0"/>
-              <a:pPr algn="ctr"/>
-              <a:t>‹#›</a:t>
-            </a:fld>
-            <a:endParaRPr lang="en-US" dirty="0"/>
-          </a:p>
-        </p:txBody>
-      </p:sp>
-      <p:sp>
-        <p:nvSpPr>
           <p:cNvPr id="7" name="Rectangle 6">
             <a:extLst>
               <a:ext uri="{FF2B5EF4-FFF2-40B4-BE49-F238E27FC236}">
@@ -2863,6 +2767,95 @@
           <a:p>
             <a:pPr algn="ctr"/>
             <a:endParaRPr lang="en-US" sz="3200"/>
+          </a:p>
+        </p:txBody>
+      </p:sp>
+      <p:sp>
+        <p:nvSpPr>
+          <p:cNvPr id="8" name="Date Placeholder 7">
+            <a:extLst>
+              <a:ext uri="{FF2B5EF4-FFF2-40B4-BE49-F238E27FC236}">
+                <a16:creationId xmlns:a16="http://schemas.microsoft.com/office/drawing/2014/main" id="{58100809-C7AD-AA37-7E54-5E07B4142DB5}"/>
+              </a:ext>
+            </a:extLst>
+          </p:cNvPr>
+          <p:cNvSpPr>
+            <a:spLocks noGrp="1"/>
+          </p:cNvSpPr>
+          <p:nvPr>
+            <p:ph type="dt" sz="half" idx="10"/>
+          </p:nvPr>
+        </p:nvSpPr>
+        <p:spPr/>
+        <p:txBody>
+          <a:bodyPr/>
+          <a:lstStyle/>
+          <a:p>
+            <a:pPr algn="ctr"/>
+            <a:r>
+              <a:rPr lang="en-US"/>
+              <a:t>DATE</a:t>
+            </a:r>
+            <a:endParaRPr lang="en-US" dirty="0"/>
+          </a:p>
+        </p:txBody>
+      </p:sp>
+      <p:sp>
+        <p:nvSpPr>
+          <p:cNvPr id="9" name="Footer Placeholder 8">
+            <a:extLst>
+              <a:ext uri="{FF2B5EF4-FFF2-40B4-BE49-F238E27FC236}">
+                <a16:creationId xmlns:a16="http://schemas.microsoft.com/office/drawing/2014/main" id="{780EC85D-71EC-E3EF-4192-AAB31D7B0AC3}"/>
+              </a:ext>
+            </a:extLst>
+          </p:cNvPr>
+          <p:cNvSpPr>
+            <a:spLocks noGrp="1"/>
+          </p:cNvSpPr>
+          <p:nvPr>
+            <p:ph type="ftr" sz="quarter" idx="11"/>
+          </p:nvPr>
+        </p:nvSpPr>
+        <p:spPr/>
+        <p:txBody>
+          <a:bodyPr/>
+          <a:lstStyle/>
+          <a:p>
+            <a:r>
+              <a:rPr lang="en-US"/>
+              <a:t>© LMU Open Science Center</a:t>
+            </a:r>
+            <a:endParaRPr lang="en-US" dirty="0"/>
+          </a:p>
+        </p:txBody>
+      </p:sp>
+      <p:sp>
+        <p:nvSpPr>
+          <p:cNvPr id="13" name="Slide Number Placeholder 12">
+            <a:extLst>
+              <a:ext uri="{FF2B5EF4-FFF2-40B4-BE49-F238E27FC236}">
+                <a16:creationId xmlns:a16="http://schemas.microsoft.com/office/drawing/2014/main" id="{76473786-B1D7-CA2F-C7C4-09172E081B28}"/>
+              </a:ext>
+            </a:extLst>
+          </p:cNvPr>
+          <p:cNvSpPr>
+            <a:spLocks noGrp="1"/>
+          </p:cNvSpPr>
+          <p:nvPr>
+            <p:ph type="sldNum" sz="quarter" idx="12"/>
+          </p:nvPr>
+        </p:nvSpPr>
+        <p:spPr/>
+        <p:txBody>
+          <a:bodyPr/>
+          <a:lstStyle/>
+          <a:p>
+            <a:fld id="{C5EF2332-01BF-834F-8236-50238282D533}" type="slidenum">
+              <a:rPr lang="en-US" smtClean="0"/>
+              <a:pPr/>
+              <a:t>‹#›</a:t>
+            </a:fld>
+            <a:endParaRPr lang="en-US" dirty="0"/>
           </a:p>
         </p:txBody>
       </p:sp>
@@ -2920,96 +2913,6 @@
       </p:sp>
       <p:sp>
         <p:nvSpPr>
-          <p:cNvPr id="6" name="Date Placeholder 5">
-            <a:extLst>
-              <a:ext uri="{FF2B5EF4-FFF2-40B4-BE49-F238E27FC236}">
-                <a16:creationId xmlns:a16="http://schemas.microsoft.com/office/drawing/2014/main" id="{EBAFF52C-BDE9-B757-3F2E-97BB80768043}"/>
-              </a:ext>
-            </a:extLst>
-          </p:cNvPr>
-          <p:cNvSpPr>
-            <a:spLocks noGrp="1"/>
-          </p:cNvSpPr>
-          <p:nvPr>
-            <p:ph type="dt" sz="half" idx="10"/>
-          </p:nvPr>
-        </p:nvSpPr>
-        <p:spPr/>
-        <p:txBody>
-          <a:bodyPr/>
-          <a:lstStyle/>
-          <a:p>
-            <a:pPr algn="ctr"/>
-            <a:r>
-              <a:rPr lang="en-US"/>
-              <a:t>DATE</a:t>
-            </a:r>
-            <a:endParaRPr lang="en-US" dirty="0"/>
-          </a:p>
-        </p:txBody>
-      </p:sp>
-      <p:sp>
-        <p:nvSpPr>
-          <p:cNvPr id="7" name="Footer Placeholder 6">
-            <a:extLst>
-              <a:ext uri="{FF2B5EF4-FFF2-40B4-BE49-F238E27FC236}">
-                <a16:creationId xmlns:a16="http://schemas.microsoft.com/office/drawing/2014/main" id="{E5405DF6-2DBE-DEB9-2870-BF132FA011E6}"/>
-              </a:ext>
-            </a:extLst>
-          </p:cNvPr>
-          <p:cNvSpPr>
-            <a:spLocks noGrp="1"/>
-          </p:cNvSpPr>
-          <p:nvPr>
-            <p:ph type="ftr" sz="quarter" idx="11"/>
-          </p:nvPr>
-        </p:nvSpPr>
-        <p:spPr/>
-        <p:txBody>
-          <a:bodyPr/>
-          <a:lstStyle/>
-          <a:p>
-            <a:r>
-              <a:rPr lang="en-US"/>
-              <a:t>© LMU Open Science Center</a:t>
-            </a:r>
-            <a:endParaRPr lang="en-US" dirty="0"/>
-          </a:p>
-        </p:txBody>
-      </p:sp>
-      <p:sp>
-        <p:nvSpPr>
-          <p:cNvPr id="8" name="Slide Number Placeholder 7">
-            <a:extLst>
-              <a:ext uri="{FF2B5EF4-FFF2-40B4-BE49-F238E27FC236}">
-                <a16:creationId xmlns:a16="http://schemas.microsoft.com/office/drawing/2014/main" id="{2168DBF4-2CFD-1E51-8AC7-982150A40374}"/>
-              </a:ext>
-            </a:extLst>
-          </p:cNvPr>
-          <p:cNvSpPr>
-            <a:spLocks noGrp="1"/>
-          </p:cNvSpPr>
-          <p:nvPr>
-            <p:ph type="sldNum" sz="quarter" idx="12"/>
-          </p:nvPr>
-        </p:nvSpPr>
-        <p:spPr/>
-        <p:txBody>
-          <a:bodyPr/>
-          <a:lstStyle/>
-          <a:p>
-            <a:pPr algn="ctr"/>
-            <a:fld id="{C5EF2332-01BF-834F-8236-50238282D533}" type="slidenum">
-              <a:rPr lang="en-US" smtClean="0"/>
-              <a:pPr algn="ctr"/>
-              <a:t>‹#›</a:t>
-            </a:fld>
-            <a:endParaRPr lang="en-US" dirty="0"/>
-          </a:p>
-        </p:txBody>
-      </p:sp>
-      <p:sp>
-        <p:nvSpPr>
           <p:cNvPr id="3" name="Rectangle 2">
             <a:extLst>
               <a:ext uri="{FF2B5EF4-FFF2-40B4-BE49-F238E27FC236}">
@@ -3055,6 +2958,95 @@
           <a:p>
             <a:pPr algn="ctr"/>
             <a:endParaRPr lang="en-US" sz="3200"/>
+          </a:p>
+        </p:txBody>
+      </p:sp>
+      <p:sp>
+        <p:nvSpPr>
+          <p:cNvPr id="4" name="Date Placeholder 3">
+            <a:extLst>
+              <a:ext uri="{FF2B5EF4-FFF2-40B4-BE49-F238E27FC236}">
+                <a16:creationId xmlns:a16="http://schemas.microsoft.com/office/drawing/2014/main" id="{B77221D3-5266-DD6F-83AC-F0960F93CB40}"/>
+              </a:ext>
+            </a:extLst>
+          </p:cNvPr>
+          <p:cNvSpPr>
+            <a:spLocks noGrp="1"/>
+          </p:cNvSpPr>
+          <p:nvPr>
+            <p:ph type="dt" sz="half" idx="10"/>
+          </p:nvPr>
+        </p:nvSpPr>
+        <p:spPr/>
+        <p:txBody>
+          <a:bodyPr/>
+          <a:lstStyle/>
+          <a:p>
+            <a:pPr algn="ctr"/>
+            <a:r>
+              <a:rPr lang="en-US"/>
+              <a:t>DATE</a:t>
+            </a:r>
+            <a:endParaRPr lang="en-US" dirty="0"/>
+          </a:p>
+        </p:txBody>
+      </p:sp>
+      <p:sp>
+        <p:nvSpPr>
+          <p:cNvPr id="5" name="Footer Placeholder 4">
+            <a:extLst>
+              <a:ext uri="{FF2B5EF4-FFF2-40B4-BE49-F238E27FC236}">
+                <a16:creationId xmlns:a16="http://schemas.microsoft.com/office/drawing/2014/main" id="{DDEB8BF7-B98F-B2C1-BBC4-836DAD84D3E3}"/>
+              </a:ext>
+            </a:extLst>
+          </p:cNvPr>
+          <p:cNvSpPr>
+            <a:spLocks noGrp="1"/>
+          </p:cNvSpPr>
+          <p:nvPr>
+            <p:ph type="ftr" sz="quarter" idx="11"/>
+          </p:nvPr>
+        </p:nvSpPr>
+        <p:spPr/>
+        <p:txBody>
+          <a:bodyPr/>
+          <a:lstStyle/>
+          <a:p>
+            <a:r>
+              <a:rPr lang="en-US"/>
+              <a:t>© LMU Open Science Center</a:t>
+            </a:r>
+            <a:endParaRPr lang="en-US" dirty="0"/>
+          </a:p>
+        </p:txBody>
+      </p:sp>
+      <p:sp>
+        <p:nvSpPr>
+          <p:cNvPr id="9" name="Slide Number Placeholder 8">
+            <a:extLst>
+              <a:ext uri="{FF2B5EF4-FFF2-40B4-BE49-F238E27FC236}">
+                <a16:creationId xmlns:a16="http://schemas.microsoft.com/office/drawing/2014/main" id="{65B4E053-B4BD-4273-20F1-F1F6E73ED32B}"/>
+              </a:ext>
+            </a:extLst>
+          </p:cNvPr>
+          <p:cNvSpPr>
+            <a:spLocks noGrp="1"/>
+          </p:cNvSpPr>
+          <p:nvPr>
+            <p:ph type="sldNum" sz="quarter" idx="12"/>
+          </p:nvPr>
+        </p:nvSpPr>
+        <p:spPr/>
+        <p:txBody>
+          <a:bodyPr/>
+          <a:lstStyle/>
+          <a:p>
+            <a:fld id="{C5EF2332-01BF-834F-8236-50238282D533}" type="slidenum">
+              <a:rPr lang="en-US" smtClean="0"/>
+              <a:pPr/>
+              <a:t>‹#›</a:t>
+            </a:fld>
+            <a:endParaRPr lang="en-US" dirty="0"/>
           </a:p>
         </p:txBody>
       </p:sp>
@@ -3090,96 +3082,6 @@
       </p:grpSpPr>
       <p:sp>
         <p:nvSpPr>
-          <p:cNvPr id="5" name="Date Placeholder 4">
-            <a:extLst>
-              <a:ext uri="{FF2B5EF4-FFF2-40B4-BE49-F238E27FC236}">
-                <a16:creationId xmlns:a16="http://schemas.microsoft.com/office/drawing/2014/main" id="{809DEAED-D9B3-6E1B-0491-58CD791C90BA}"/>
-              </a:ext>
-            </a:extLst>
-          </p:cNvPr>
-          <p:cNvSpPr>
-            <a:spLocks noGrp="1"/>
-          </p:cNvSpPr>
-          <p:nvPr>
-            <p:ph type="dt" sz="half" idx="10"/>
-          </p:nvPr>
-        </p:nvSpPr>
-        <p:spPr/>
-        <p:txBody>
-          <a:bodyPr/>
-          <a:lstStyle/>
-          <a:p>
-            <a:pPr algn="ctr"/>
-            <a:r>
-              <a:rPr lang="en-US"/>
-              <a:t>DATE</a:t>
-            </a:r>
-            <a:endParaRPr lang="en-US" dirty="0"/>
-          </a:p>
-        </p:txBody>
-      </p:sp>
-      <p:sp>
-        <p:nvSpPr>
-          <p:cNvPr id="6" name="Footer Placeholder 5">
-            <a:extLst>
-              <a:ext uri="{FF2B5EF4-FFF2-40B4-BE49-F238E27FC236}">
-                <a16:creationId xmlns:a16="http://schemas.microsoft.com/office/drawing/2014/main" id="{77F0CD55-CE9E-DB6C-0EC3-1B10A9E5C45B}"/>
-              </a:ext>
-            </a:extLst>
-          </p:cNvPr>
-          <p:cNvSpPr>
-            <a:spLocks noGrp="1"/>
-          </p:cNvSpPr>
-          <p:nvPr>
-            <p:ph type="ftr" sz="quarter" idx="11"/>
-          </p:nvPr>
-        </p:nvSpPr>
-        <p:spPr/>
-        <p:txBody>
-          <a:bodyPr/>
-          <a:lstStyle/>
-          <a:p>
-            <a:r>
-              <a:rPr lang="en-US"/>
-              <a:t>© LMU Open Science Center</a:t>
-            </a:r>
-            <a:endParaRPr lang="en-US" dirty="0"/>
-          </a:p>
-        </p:txBody>
-      </p:sp>
-      <p:sp>
-        <p:nvSpPr>
-          <p:cNvPr id="7" name="Slide Number Placeholder 6">
-            <a:extLst>
-              <a:ext uri="{FF2B5EF4-FFF2-40B4-BE49-F238E27FC236}">
-                <a16:creationId xmlns:a16="http://schemas.microsoft.com/office/drawing/2014/main" id="{E9FEDD56-48D3-8D4B-FA52-B62AB7006E2A}"/>
-              </a:ext>
-            </a:extLst>
-          </p:cNvPr>
-          <p:cNvSpPr>
-            <a:spLocks noGrp="1"/>
-          </p:cNvSpPr>
-          <p:nvPr>
-            <p:ph type="sldNum" sz="quarter" idx="12"/>
-          </p:nvPr>
-        </p:nvSpPr>
-        <p:spPr/>
-        <p:txBody>
-          <a:bodyPr/>
-          <a:lstStyle/>
-          <a:p>
-            <a:pPr algn="ctr"/>
-            <a:fld id="{C5EF2332-01BF-834F-8236-50238282D533}" type="slidenum">
-              <a:rPr lang="en-US" smtClean="0"/>
-              <a:pPr algn="ctr"/>
-              <a:t>‹#›</a:t>
-            </a:fld>
-            <a:endParaRPr lang="en-US" dirty="0"/>
-          </a:p>
-        </p:txBody>
-      </p:sp>
-      <p:sp>
-        <p:nvSpPr>
           <p:cNvPr id="2" name="Rectangle 1">
             <a:extLst>
               <a:ext uri="{FF2B5EF4-FFF2-40B4-BE49-F238E27FC236}">
@@ -3225,6 +3127,95 @@
           <a:p>
             <a:pPr algn="ctr"/>
             <a:endParaRPr lang="en-US" sz="3200"/>
+          </a:p>
+        </p:txBody>
+      </p:sp>
+      <p:sp>
+        <p:nvSpPr>
+          <p:cNvPr id="3" name="Date Placeholder 2">
+            <a:extLst>
+              <a:ext uri="{FF2B5EF4-FFF2-40B4-BE49-F238E27FC236}">
+                <a16:creationId xmlns:a16="http://schemas.microsoft.com/office/drawing/2014/main" id="{A524AD1A-09DE-80F2-211E-50D2602CBB2F}"/>
+              </a:ext>
+            </a:extLst>
+          </p:cNvPr>
+          <p:cNvSpPr>
+            <a:spLocks noGrp="1"/>
+          </p:cNvSpPr>
+          <p:nvPr>
+            <p:ph type="dt" sz="half" idx="10"/>
+          </p:nvPr>
+        </p:nvSpPr>
+        <p:spPr/>
+        <p:txBody>
+          <a:bodyPr/>
+          <a:lstStyle/>
+          <a:p>
+            <a:pPr algn="ctr"/>
+            <a:r>
+              <a:rPr lang="en-US"/>
+              <a:t>DATE</a:t>
+            </a:r>
+            <a:endParaRPr lang="en-US" dirty="0"/>
+          </a:p>
+        </p:txBody>
+      </p:sp>
+      <p:sp>
+        <p:nvSpPr>
+          <p:cNvPr id="4" name="Footer Placeholder 3">
+            <a:extLst>
+              <a:ext uri="{FF2B5EF4-FFF2-40B4-BE49-F238E27FC236}">
+                <a16:creationId xmlns:a16="http://schemas.microsoft.com/office/drawing/2014/main" id="{C64D603C-1DE0-937A-1F64-CF31D2545F5B}"/>
+              </a:ext>
+            </a:extLst>
+          </p:cNvPr>
+          <p:cNvSpPr>
+            <a:spLocks noGrp="1"/>
+          </p:cNvSpPr>
+          <p:nvPr>
+            <p:ph type="ftr" sz="quarter" idx="11"/>
+          </p:nvPr>
+        </p:nvSpPr>
+        <p:spPr/>
+        <p:txBody>
+          <a:bodyPr/>
+          <a:lstStyle/>
+          <a:p>
+            <a:r>
+              <a:rPr lang="en-US"/>
+              <a:t>© LMU Open Science Center</a:t>
+            </a:r>
+            <a:endParaRPr lang="en-US" dirty="0"/>
+          </a:p>
+        </p:txBody>
+      </p:sp>
+      <p:sp>
+        <p:nvSpPr>
+          <p:cNvPr id="8" name="Slide Number Placeholder 7">
+            <a:extLst>
+              <a:ext uri="{FF2B5EF4-FFF2-40B4-BE49-F238E27FC236}">
+                <a16:creationId xmlns:a16="http://schemas.microsoft.com/office/drawing/2014/main" id="{659CFA45-E807-CF9C-9148-21ED45D59DB5}"/>
+              </a:ext>
+            </a:extLst>
+          </p:cNvPr>
+          <p:cNvSpPr>
+            <a:spLocks noGrp="1"/>
+          </p:cNvSpPr>
+          <p:nvPr>
+            <p:ph type="sldNum" sz="quarter" idx="12"/>
+          </p:nvPr>
+        </p:nvSpPr>
+        <p:spPr/>
+        <p:txBody>
+          <a:bodyPr/>
+          <a:lstStyle/>
+          <a:p>
+            <a:fld id="{C5EF2332-01BF-834F-8236-50238282D533}" type="slidenum">
+              <a:rPr lang="en-US" smtClean="0"/>
+              <a:pPr/>
+              <a:t>‹#›</a:t>
+            </a:fld>
+            <a:endParaRPr lang="en-US" dirty="0"/>
           </a:p>
         </p:txBody>
       </p:sp>
@@ -3440,96 +3431,6 @@
       </p:sp>
       <p:sp>
         <p:nvSpPr>
-          <p:cNvPr id="8" name="Date Placeholder 7">
-            <a:extLst>
-              <a:ext uri="{FF2B5EF4-FFF2-40B4-BE49-F238E27FC236}">
-                <a16:creationId xmlns:a16="http://schemas.microsoft.com/office/drawing/2014/main" id="{E6D5126F-053F-910F-7F76-D928AC61372D}"/>
-              </a:ext>
-            </a:extLst>
-          </p:cNvPr>
-          <p:cNvSpPr>
-            <a:spLocks noGrp="1"/>
-          </p:cNvSpPr>
-          <p:nvPr>
-            <p:ph type="dt" sz="half" idx="10"/>
-          </p:nvPr>
-        </p:nvSpPr>
-        <p:spPr/>
-        <p:txBody>
-          <a:bodyPr/>
-          <a:lstStyle/>
-          <a:p>
-            <a:pPr algn="ctr"/>
-            <a:r>
-              <a:rPr lang="en-US"/>
-              <a:t>DATE</a:t>
-            </a:r>
-            <a:endParaRPr lang="en-US" dirty="0"/>
-          </a:p>
-        </p:txBody>
-      </p:sp>
-      <p:sp>
-        <p:nvSpPr>
-          <p:cNvPr id="9" name="Footer Placeholder 8">
-            <a:extLst>
-              <a:ext uri="{FF2B5EF4-FFF2-40B4-BE49-F238E27FC236}">
-                <a16:creationId xmlns:a16="http://schemas.microsoft.com/office/drawing/2014/main" id="{8EEF7D04-FF72-0698-CE48-A9A4F70D774F}"/>
-              </a:ext>
-            </a:extLst>
-          </p:cNvPr>
-          <p:cNvSpPr>
-            <a:spLocks noGrp="1"/>
-          </p:cNvSpPr>
-          <p:nvPr>
-            <p:ph type="ftr" sz="quarter" idx="11"/>
-          </p:nvPr>
-        </p:nvSpPr>
-        <p:spPr/>
-        <p:txBody>
-          <a:bodyPr/>
-          <a:lstStyle/>
-          <a:p>
-            <a:r>
-              <a:rPr lang="en-US"/>
-              <a:t>© LMU Open Science Center</a:t>
-            </a:r>
-            <a:endParaRPr lang="en-US" dirty="0"/>
-          </a:p>
-        </p:txBody>
-      </p:sp>
-      <p:sp>
-        <p:nvSpPr>
-          <p:cNvPr id="10" name="Slide Number Placeholder 9">
-            <a:extLst>
-              <a:ext uri="{FF2B5EF4-FFF2-40B4-BE49-F238E27FC236}">
-                <a16:creationId xmlns:a16="http://schemas.microsoft.com/office/drawing/2014/main" id="{C8B1F07D-59FC-87D1-1BB5-7C86711059AF}"/>
-              </a:ext>
-            </a:extLst>
-          </p:cNvPr>
-          <p:cNvSpPr>
-            <a:spLocks noGrp="1"/>
-          </p:cNvSpPr>
-          <p:nvPr>
-            <p:ph type="sldNum" sz="quarter" idx="12"/>
-          </p:nvPr>
-        </p:nvSpPr>
-        <p:spPr/>
-        <p:txBody>
-          <a:bodyPr/>
-          <a:lstStyle/>
-          <a:p>
-            <a:pPr algn="ctr"/>
-            <a:fld id="{C5EF2332-01BF-834F-8236-50238282D533}" type="slidenum">
-              <a:rPr lang="en-US" smtClean="0"/>
-              <a:pPr algn="ctr"/>
-              <a:t>‹#›</a:t>
-            </a:fld>
-            <a:endParaRPr lang="en-US" dirty="0"/>
-          </a:p>
-        </p:txBody>
-      </p:sp>
-      <p:sp>
-        <p:nvSpPr>
           <p:cNvPr id="5" name="Rectangle 4">
             <a:extLst>
               <a:ext uri="{FF2B5EF4-FFF2-40B4-BE49-F238E27FC236}">
@@ -3575,6 +3476,95 @@
           <a:p>
             <a:pPr algn="ctr"/>
             <a:endParaRPr lang="en-US" sz="3200"/>
+          </a:p>
+        </p:txBody>
+      </p:sp>
+      <p:sp>
+        <p:nvSpPr>
+          <p:cNvPr id="6" name="Date Placeholder 5">
+            <a:extLst>
+              <a:ext uri="{FF2B5EF4-FFF2-40B4-BE49-F238E27FC236}">
+                <a16:creationId xmlns:a16="http://schemas.microsoft.com/office/drawing/2014/main" id="{4D4823E0-4AC4-556E-D341-7EC0B24627F1}"/>
+              </a:ext>
+            </a:extLst>
+          </p:cNvPr>
+          <p:cNvSpPr>
+            <a:spLocks noGrp="1"/>
+          </p:cNvSpPr>
+          <p:nvPr>
+            <p:ph type="dt" sz="half" idx="10"/>
+          </p:nvPr>
+        </p:nvSpPr>
+        <p:spPr/>
+        <p:txBody>
+          <a:bodyPr/>
+          <a:lstStyle/>
+          <a:p>
+            <a:pPr algn="ctr"/>
+            <a:r>
+              <a:rPr lang="en-US"/>
+              <a:t>DATE</a:t>
+            </a:r>
+            <a:endParaRPr lang="en-US" dirty="0"/>
+          </a:p>
+        </p:txBody>
+      </p:sp>
+      <p:sp>
+        <p:nvSpPr>
+          <p:cNvPr id="7" name="Footer Placeholder 6">
+            <a:extLst>
+              <a:ext uri="{FF2B5EF4-FFF2-40B4-BE49-F238E27FC236}">
+                <a16:creationId xmlns:a16="http://schemas.microsoft.com/office/drawing/2014/main" id="{DA033808-7DA7-BCE5-7841-A080B9791E38}"/>
+              </a:ext>
+            </a:extLst>
+          </p:cNvPr>
+          <p:cNvSpPr>
+            <a:spLocks noGrp="1"/>
+          </p:cNvSpPr>
+          <p:nvPr>
+            <p:ph type="ftr" sz="quarter" idx="11"/>
+          </p:nvPr>
+        </p:nvSpPr>
+        <p:spPr/>
+        <p:txBody>
+          <a:bodyPr/>
+          <a:lstStyle/>
+          <a:p>
+            <a:r>
+              <a:rPr lang="en-US"/>
+              <a:t>© LMU Open Science Center</a:t>
+            </a:r>
+            <a:endParaRPr lang="en-US" dirty="0"/>
+          </a:p>
+        </p:txBody>
+      </p:sp>
+      <p:sp>
+        <p:nvSpPr>
+          <p:cNvPr id="11" name="Slide Number Placeholder 10">
+            <a:extLst>
+              <a:ext uri="{FF2B5EF4-FFF2-40B4-BE49-F238E27FC236}">
+                <a16:creationId xmlns:a16="http://schemas.microsoft.com/office/drawing/2014/main" id="{F114B9F3-9BDF-91CE-CDEA-A368776345DA}"/>
+              </a:ext>
+            </a:extLst>
+          </p:cNvPr>
+          <p:cNvSpPr>
+            <a:spLocks noGrp="1"/>
+          </p:cNvSpPr>
+          <p:nvPr>
+            <p:ph type="sldNum" sz="quarter" idx="12"/>
+          </p:nvPr>
+        </p:nvSpPr>
+        <p:spPr/>
+        <p:txBody>
+          <a:bodyPr/>
+          <a:lstStyle/>
+          <a:p>
+            <a:fld id="{C5EF2332-01BF-834F-8236-50238282D533}" type="slidenum">
+              <a:rPr lang="en-US" smtClean="0"/>
+              <a:pPr/>
+              <a:t>‹#›</a:t>
+            </a:fld>
+            <a:endParaRPr lang="en-US" dirty="0"/>
           </a:p>
         </p:txBody>
       </p:sp>
@@ -3767,96 +3757,6 @@
       </p:sp>
       <p:sp>
         <p:nvSpPr>
-          <p:cNvPr id="8" name="Date Placeholder 7">
-            <a:extLst>
-              <a:ext uri="{FF2B5EF4-FFF2-40B4-BE49-F238E27FC236}">
-                <a16:creationId xmlns:a16="http://schemas.microsoft.com/office/drawing/2014/main" id="{29EE7C5F-ABAD-CC52-7A14-40327B8307C5}"/>
-              </a:ext>
-            </a:extLst>
-          </p:cNvPr>
-          <p:cNvSpPr>
-            <a:spLocks noGrp="1"/>
-          </p:cNvSpPr>
-          <p:nvPr>
-            <p:ph type="dt" sz="half" idx="10"/>
-          </p:nvPr>
-        </p:nvSpPr>
-        <p:spPr/>
-        <p:txBody>
-          <a:bodyPr/>
-          <a:lstStyle/>
-          <a:p>
-            <a:pPr algn="ctr"/>
-            <a:r>
-              <a:rPr lang="en-US"/>
-              <a:t>DATE</a:t>
-            </a:r>
-            <a:endParaRPr lang="en-US" dirty="0"/>
-          </a:p>
-        </p:txBody>
-      </p:sp>
-      <p:sp>
-        <p:nvSpPr>
-          <p:cNvPr id="9" name="Footer Placeholder 8">
-            <a:extLst>
-              <a:ext uri="{FF2B5EF4-FFF2-40B4-BE49-F238E27FC236}">
-                <a16:creationId xmlns:a16="http://schemas.microsoft.com/office/drawing/2014/main" id="{DB013600-FEC1-B326-2FA5-44299E5168AB}"/>
-              </a:ext>
-            </a:extLst>
-          </p:cNvPr>
-          <p:cNvSpPr>
-            <a:spLocks noGrp="1"/>
-          </p:cNvSpPr>
-          <p:nvPr>
-            <p:ph type="ftr" sz="quarter" idx="11"/>
-          </p:nvPr>
-        </p:nvSpPr>
-        <p:spPr/>
-        <p:txBody>
-          <a:bodyPr/>
-          <a:lstStyle/>
-          <a:p>
-            <a:r>
-              <a:rPr lang="en-US"/>
-              <a:t>© LMU Open Science Center</a:t>
-            </a:r>
-            <a:endParaRPr lang="en-US" dirty="0"/>
-          </a:p>
-        </p:txBody>
-      </p:sp>
-      <p:sp>
-        <p:nvSpPr>
-          <p:cNvPr id="10" name="Slide Number Placeholder 9">
-            <a:extLst>
-              <a:ext uri="{FF2B5EF4-FFF2-40B4-BE49-F238E27FC236}">
-                <a16:creationId xmlns:a16="http://schemas.microsoft.com/office/drawing/2014/main" id="{15CA6B3C-BACA-8A65-B5EF-54019213DBD8}"/>
-              </a:ext>
-            </a:extLst>
-          </p:cNvPr>
-          <p:cNvSpPr>
-            <a:spLocks noGrp="1"/>
-          </p:cNvSpPr>
-          <p:nvPr>
-            <p:ph type="sldNum" sz="quarter" idx="12"/>
-          </p:nvPr>
-        </p:nvSpPr>
-        <p:spPr/>
-        <p:txBody>
-          <a:bodyPr/>
-          <a:lstStyle/>
-          <a:p>
-            <a:pPr algn="ctr"/>
-            <a:fld id="{C5EF2332-01BF-834F-8236-50238282D533}" type="slidenum">
-              <a:rPr lang="en-US" smtClean="0"/>
-              <a:pPr algn="ctr"/>
-              <a:t>‹#›</a:t>
-            </a:fld>
-            <a:endParaRPr lang="en-US" dirty="0"/>
-          </a:p>
-        </p:txBody>
-      </p:sp>
-      <p:sp>
-        <p:nvSpPr>
           <p:cNvPr id="5" name="Rectangle 4">
             <a:extLst>
               <a:ext uri="{FF2B5EF4-FFF2-40B4-BE49-F238E27FC236}">
@@ -3902,6 +3802,95 @@
           <a:p>
             <a:pPr algn="ctr"/>
             <a:endParaRPr lang="en-US" sz="3200"/>
+          </a:p>
+        </p:txBody>
+      </p:sp>
+      <p:sp>
+        <p:nvSpPr>
+          <p:cNvPr id="6" name="Date Placeholder 5">
+            <a:extLst>
+              <a:ext uri="{FF2B5EF4-FFF2-40B4-BE49-F238E27FC236}">
+                <a16:creationId xmlns:a16="http://schemas.microsoft.com/office/drawing/2014/main" id="{BEDD9C9F-3905-36C7-15CB-BACF4406BE2F}"/>
+              </a:ext>
+            </a:extLst>
+          </p:cNvPr>
+          <p:cNvSpPr>
+            <a:spLocks noGrp="1"/>
+          </p:cNvSpPr>
+          <p:nvPr>
+            <p:ph type="dt" sz="half" idx="10"/>
+          </p:nvPr>
+        </p:nvSpPr>
+        <p:spPr/>
+        <p:txBody>
+          <a:bodyPr/>
+          <a:lstStyle/>
+          <a:p>
+            <a:pPr algn="ctr"/>
+            <a:r>
+              <a:rPr lang="en-US"/>
+              <a:t>DATE</a:t>
+            </a:r>
+            <a:endParaRPr lang="en-US" dirty="0"/>
+          </a:p>
+        </p:txBody>
+      </p:sp>
+      <p:sp>
+        <p:nvSpPr>
+          <p:cNvPr id="7" name="Footer Placeholder 6">
+            <a:extLst>
+              <a:ext uri="{FF2B5EF4-FFF2-40B4-BE49-F238E27FC236}">
+                <a16:creationId xmlns:a16="http://schemas.microsoft.com/office/drawing/2014/main" id="{FB50E993-3E74-7605-4B1C-089FC5994AF0}"/>
+              </a:ext>
+            </a:extLst>
+          </p:cNvPr>
+          <p:cNvSpPr>
+            <a:spLocks noGrp="1"/>
+          </p:cNvSpPr>
+          <p:nvPr>
+            <p:ph type="ftr" sz="quarter" idx="11"/>
+          </p:nvPr>
+        </p:nvSpPr>
+        <p:spPr/>
+        <p:txBody>
+          <a:bodyPr/>
+          <a:lstStyle/>
+          <a:p>
+            <a:r>
+              <a:rPr lang="en-US"/>
+              <a:t>© LMU Open Science Center</a:t>
+            </a:r>
+            <a:endParaRPr lang="en-US" dirty="0"/>
+          </a:p>
+        </p:txBody>
+      </p:sp>
+      <p:sp>
+        <p:nvSpPr>
+          <p:cNvPr id="11" name="Slide Number Placeholder 10">
+            <a:extLst>
+              <a:ext uri="{FF2B5EF4-FFF2-40B4-BE49-F238E27FC236}">
+                <a16:creationId xmlns:a16="http://schemas.microsoft.com/office/drawing/2014/main" id="{AA2A021D-E01D-7241-598C-56E146616C09}"/>
+              </a:ext>
+            </a:extLst>
+          </p:cNvPr>
+          <p:cNvSpPr>
+            <a:spLocks noGrp="1"/>
+          </p:cNvSpPr>
+          <p:nvPr>
+            <p:ph type="sldNum" sz="quarter" idx="12"/>
+          </p:nvPr>
+        </p:nvSpPr>
+        <p:spPr/>
+        <p:txBody>
+          <a:bodyPr/>
+          <a:lstStyle/>
+          <a:p>
+            <a:fld id="{C5EF2332-01BF-834F-8236-50238282D533}" type="slidenum">
+              <a:rPr lang="en-US" smtClean="0"/>
+              <a:pPr/>
+              <a:t>‹#›</a:t>
+            </a:fld>
+            <a:endParaRPr lang="en-US" dirty="0"/>
           </a:p>
         </p:txBody>
       </p:sp>
@@ -4127,7 +4116,7 @@
         </p:nvSpPr>
         <p:spPr>
           <a:xfrm>
-            <a:off x="7712559" y="6365488"/>
+            <a:off x="9763932" y="6365488"/>
             <a:ext cx="1818468" cy="298453"/>
           </a:xfrm>
           <a:prstGeom prst="rect">
@@ -4148,10 +4137,9 @@
             </a:lvl1pPr>
           </a:lstStyle>
           <a:p>
-            <a:pPr algn="ctr"/>
             <a:fld id="{C5EF2332-01BF-834F-8236-50238282D533}" type="slidenum">
               <a:rPr lang="en-US" smtClean="0"/>
-              <a:pPr algn="ctr"/>
+              <a:pPr/>
               <a:t>‹#›</a:t>
             </a:fld>
             <a:endParaRPr lang="en-US" dirty="0"/>

</xml_diff>

<commit_message>
Update some font sizing differences
</commit_message>
<xml_diff>
--- a/working-template.pptx
+++ b/working-template.pptx
@@ -1021,35 +1021,35 @@
           <a:p>
             <a:pPr lvl="0"/>
             <a:r>
-              <a:rPr lang="en-US"/>
+              <a:rPr lang="en-US" dirty="0"/>
               <a:t>Click to edit Master text styles</a:t>
             </a:r>
           </a:p>
           <a:p>
             <a:pPr lvl="1"/>
             <a:r>
-              <a:rPr lang="en-US"/>
+              <a:rPr lang="en-US" dirty="0"/>
               <a:t>Second level</a:t>
             </a:r>
           </a:p>
           <a:p>
             <a:pPr lvl="2"/>
             <a:r>
-              <a:rPr lang="en-US"/>
+              <a:rPr lang="en-US" dirty="0"/>
               <a:t>Third level</a:t>
             </a:r>
           </a:p>
           <a:p>
             <a:pPr lvl="3"/>
             <a:r>
-              <a:rPr lang="en-US"/>
+              <a:rPr lang="en-US" dirty="0"/>
               <a:t>Fourth level</a:t>
             </a:r>
           </a:p>
           <a:p>
             <a:pPr lvl="4"/>
             <a:r>
-              <a:rPr lang="en-US"/>
+              <a:rPr lang="en-US" dirty="0"/>
               <a:t>Fifth level</a:t>
             </a:r>
           </a:p>
@@ -1273,35 +1273,35 @@
           <a:p>
             <a:pPr lvl="0"/>
             <a:r>
-              <a:rPr lang="en-US"/>
+              <a:rPr lang="en-US" dirty="0"/>
               <a:t>Click to edit Master text styles</a:t>
             </a:r>
           </a:p>
           <a:p>
             <a:pPr lvl="1"/>
             <a:r>
-              <a:rPr lang="en-US"/>
+              <a:rPr lang="en-US" dirty="0"/>
               <a:t>Second level</a:t>
             </a:r>
           </a:p>
           <a:p>
             <a:pPr lvl="2"/>
             <a:r>
-              <a:rPr lang="en-US"/>
+              <a:rPr lang="en-US" dirty="0"/>
               <a:t>Third level</a:t>
             </a:r>
           </a:p>
           <a:p>
             <a:pPr lvl="3"/>
             <a:r>
-              <a:rPr lang="en-US"/>
+              <a:rPr lang="en-US" dirty="0"/>
               <a:t>Fourth level</a:t>
             </a:r>
           </a:p>
           <a:p>
             <a:pPr lvl="4"/>
             <a:r>
-              <a:rPr lang="en-US"/>
+              <a:rPr lang="en-US" dirty="0"/>
               <a:t>Fifth level</a:t>
             </a:r>
           </a:p>
@@ -2079,19 +2079,19 @@
           <a:bodyPr/>
           <a:lstStyle>
             <a:lvl1pPr>
-              <a:defRPr sz="2800"/>
+              <a:defRPr sz="2200"/>
             </a:lvl1pPr>
             <a:lvl2pPr>
-              <a:defRPr sz="2400"/>
+              <a:defRPr sz="2000"/>
             </a:lvl2pPr>
             <a:lvl3pPr>
-              <a:defRPr sz="2000"/>
+              <a:defRPr sz="1800"/>
             </a:lvl3pPr>
             <a:lvl4pPr>
-              <a:defRPr sz="1800"/>
+              <a:defRPr sz="1600"/>
             </a:lvl4pPr>
             <a:lvl5pPr>
-              <a:defRPr sz="1800"/>
+              <a:defRPr sz="1600"/>
             </a:lvl5pPr>
             <a:lvl6pPr>
               <a:defRPr sz="1800"/>
@@ -2109,35 +2109,35 @@
           <a:p>
             <a:pPr lvl="0"/>
             <a:r>
-              <a:rPr lang="en-US"/>
+              <a:rPr lang="en-US" dirty="0"/>
               <a:t>Click to edit Master text styles</a:t>
             </a:r>
           </a:p>
           <a:p>
             <a:pPr lvl="1"/>
             <a:r>
-              <a:rPr lang="en-US"/>
+              <a:rPr lang="en-US" dirty="0"/>
               <a:t>Second level</a:t>
             </a:r>
           </a:p>
           <a:p>
             <a:pPr lvl="2"/>
             <a:r>
-              <a:rPr lang="en-US"/>
+              <a:rPr lang="en-US" dirty="0"/>
               <a:t>Third level</a:t>
             </a:r>
           </a:p>
           <a:p>
             <a:pPr lvl="3"/>
             <a:r>
-              <a:rPr lang="en-US"/>
+              <a:rPr lang="en-US" dirty="0"/>
               <a:t>Fourth level</a:t>
             </a:r>
           </a:p>
           <a:p>
             <a:pPr lvl="4"/>
             <a:r>
-              <a:rPr lang="en-US"/>
+              <a:rPr lang="en-US" dirty="0"/>
               <a:t>Fifth level</a:t>
             </a:r>
           </a:p>
@@ -2163,19 +2163,19 @@
           <a:bodyPr/>
           <a:lstStyle>
             <a:lvl1pPr>
-              <a:defRPr sz="2800"/>
+              <a:defRPr sz="2200"/>
             </a:lvl1pPr>
             <a:lvl2pPr>
-              <a:defRPr sz="2400"/>
+              <a:defRPr sz="2000"/>
             </a:lvl2pPr>
             <a:lvl3pPr>
-              <a:defRPr sz="2000"/>
+              <a:defRPr sz="1800"/>
             </a:lvl3pPr>
             <a:lvl4pPr>
-              <a:defRPr sz="1800"/>
+              <a:defRPr sz="1600"/>
             </a:lvl4pPr>
             <a:lvl5pPr>
-              <a:defRPr sz="1800"/>
+              <a:defRPr sz="1600"/>
             </a:lvl5pPr>
             <a:lvl6pPr>
               <a:defRPr sz="1800"/>
@@ -2193,35 +2193,35 @@
           <a:p>
             <a:pPr lvl="0"/>
             <a:r>
-              <a:rPr lang="en-US"/>
+              <a:rPr lang="en-US" dirty="0"/>
               <a:t>Click to edit Master text styles</a:t>
             </a:r>
           </a:p>
           <a:p>
             <a:pPr lvl="1"/>
             <a:r>
-              <a:rPr lang="en-US"/>
+              <a:rPr lang="en-US" dirty="0"/>
               <a:t>Second level</a:t>
             </a:r>
           </a:p>
           <a:p>
             <a:pPr lvl="2"/>
             <a:r>
-              <a:rPr lang="en-US"/>
+              <a:rPr lang="en-US" dirty="0"/>
               <a:t>Third level</a:t>
             </a:r>
           </a:p>
           <a:p>
             <a:pPr lvl="3"/>
             <a:r>
-              <a:rPr lang="en-US"/>
+              <a:rPr lang="en-US" dirty="0"/>
               <a:t>Fourth level</a:t>
             </a:r>
           </a:p>
           <a:p>
             <a:pPr lvl="4"/>
             <a:r>
-              <a:rPr lang="en-US"/>
+              <a:rPr lang="en-US" dirty="0"/>
               <a:t>Fifth level</a:t>
             </a:r>
           </a:p>
@@ -2416,7 +2416,7 @@
           </a:lstStyle>
           <a:p>
             <a:r>
-              <a:rPr lang="en-US"/>
+              <a:rPr lang="en-US" dirty="0"/>
               <a:t>Click to edit Master title style</a:t>
             </a:r>
           </a:p>
@@ -2507,7 +2507,7 @@
           <a:bodyPr/>
           <a:lstStyle>
             <a:lvl1pPr>
-              <a:defRPr sz="2400"/>
+              <a:defRPr sz="2200"/>
             </a:lvl1pPr>
             <a:lvl2pPr>
               <a:defRPr sz="2000"/>
@@ -2537,35 +2537,35 @@
           <a:p>
             <a:pPr lvl="0"/>
             <a:r>
-              <a:rPr lang="en-US"/>
+              <a:rPr lang="en-US" dirty="0"/>
               <a:t>Click to edit Master text styles</a:t>
             </a:r>
           </a:p>
           <a:p>
             <a:pPr lvl="1"/>
             <a:r>
-              <a:rPr lang="en-US"/>
+              <a:rPr lang="en-US" dirty="0"/>
               <a:t>Second level</a:t>
             </a:r>
           </a:p>
           <a:p>
             <a:pPr lvl="2"/>
             <a:r>
-              <a:rPr lang="en-US"/>
+              <a:rPr lang="en-US" dirty="0"/>
               <a:t>Third level</a:t>
             </a:r>
           </a:p>
           <a:p>
             <a:pPr lvl="3"/>
             <a:r>
-              <a:rPr lang="en-US"/>
+              <a:rPr lang="en-US" dirty="0"/>
               <a:t>Fourth level</a:t>
             </a:r>
           </a:p>
           <a:p>
             <a:pPr lvl="4"/>
             <a:r>
-              <a:rPr lang="en-US"/>
+              <a:rPr lang="en-US" dirty="0"/>
               <a:t>Fifth level</a:t>
             </a:r>
           </a:p>
@@ -2656,7 +2656,7 @@
           <a:bodyPr/>
           <a:lstStyle>
             <a:lvl1pPr>
-              <a:defRPr sz="2400"/>
+              <a:defRPr sz="2200"/>
             </a:lvl1pPr>
             <a:lvl2pPr>
               <a:defRPr sz="2000"/>
@@ -2686,35 +2686,35 @@
           <a:p>
             <a:pPr lvl="0"/>
             <a:r>
-              <a:rPr lang="en-US"/>
+              <a:rPr lang="en-US" dirty="0"/>
               <a:t>Click to edit Master text styles</a:t>
             </a:r>
           </a:p>
           <a:p>
             <a:pPr lvl="1"/>
             <a:r>
-              <a:rPr lang="en-US"/>
+              <a:rPr lang="en-US" dirty="0"/>
               <a:t>Second level</a:t>
             </a:r>
           </a:p>
           <a:p>
             <a:pPr lvl="2"/>
             <a:r>
-              <a:rPr lang="en-US"/>
+              <a:rPr lang="en-US" dirty="0"/>
               <a:t>Third level</a:t>
             </a:r>
           </a:p>
           <a:p>
             <a:pPr lvl="3"/>
             <a:r>
-              <a:rPr lang="en-US"/>
+              <a:rPr lang="en-US" dirty="0"/>
               <a:t>Fourth level</a:t>
             </a:r>
           </a:p>
           <a:p>
             <a:pPr lvl="4"/>
             <a:r>
-              <a:rPr lang="en-US"/>
+              <a:rPr lang="en-US" dirty="0"/>
               <a:t>Fifth level</a:t>
             </a:r>
           </a:p>
@@ -3269,12 +3269,12 @@
           <a:bodyPr anchor="b"/>
           <a:lstStyle>
             <a:lvl1pPr algn="l">
-              <a:defRPr sz="2000" b="1"/>
+              <a:defRPr sz="2200" b="1"/>
             </a:lvl1pPr>
           </a:lstStyle>
           <a:p>
             <a:r>
-              <a:rPr lang="en-US"/>
+              <a:rPr lang="en-US" dirty="0"/>
               <a:t>Click to edit Master title style</a:t>
             </a:r>
           </a:p>
@@ -3300,19 +3300,19 @@
           <a:bodyPr anchor="ctr"/>
           <a:lstStyle>
             <a:lvl1pPr>
-              <a:defRPr sz="3200"/>
+              <a:defRPr sz="2200"/>
             </a:lvl1pPr>
             <a:lvl2pPr>
-              <a:defRPr sz="2800"/>
+              <a:defRPr sz="2000"/>
             </a:lvl2pPr>
             <a:lvl3pPr>
-              <a:defRPr sz="2400"/>
+              <a:defRPr sz="1800"/>
             </a:lvl3pPr>
             <a:lvl4pPr>
-              <a:defRPr sz="2000"/>
+              <a:defRPr sz="1600"/>
             </a:lvl4pPr>
             <a:lvl5pPr>
-              <a:defRPr sz="2000"/>
+              <a:defRPr sz="1600"/>
             </a:lvl5pPr>
             <a:lvl6pPr>
               <a:defRPr sz="2000"/>
@@ -3385,7 +3385,7 @@
           <a:lstStyle>
             <a:lvl1pPr marL="0" indent="0">
               <a:buNone/>
-              <a:defRPr sz="1400"/>
+              <a:defRPr sz="1600"/>
             </a:lvl1pPr>
             <a:lvl2pPr marL="457189" indent="0">
               <a:buNone/>
@@ -3423,7 +3423,7 @@
           <a:p>
             <a:pPr lvl="0"/>
             <a:r>
-              <a:rPr lang="en-US"/>
+              <a:rPr lang="en-US" dirty="0"/>
               <a:t>Click to edit Master text styles</a:t>
             </a:r>
           </a:p>
@@ -3623,7 +3623,7 @@
           </a:lstStyle>
           <a:p>
             <a:r>
-              <a:rPr lang="en-US"/>
+              <a:rPr lang="en-US" dirty="0"/>
               <a:t>Click to edit Master title style</a:t>
             </a:r>
           </a:p>

</xml_diff>

<commit_message>
Reduce box size for content with caption layout
</commit_message>
<xml_diff>
--- a/working-template.pptx
+++ b/working-template.pptx
@@ -3292,8 +3292,8 @@
         </p:nvSpPr>
         <p:spPr>
           <a:xfrm>
-            <a:off x="4766733" y="273052"/>
-            <a:ext cx="6815667" cy="5853113"/>
+            <a:off x="4766733" y="1435100"/>
+            <a:ext cx="6815667" cy="4691065"/>
           </a:xfrm>
         </p:spPr>
         <p:txBody>

</xml_diff>